<commit_message>
fix(docs): perfect image aspect ratios, prevent cutoffs, and provide wide showcase for 8 screens
</commit_message>
<xml_diff>
--- a/docs/PRM323_Lab2_Nhom4_Slides.pptx
+++ b/docs/PRM323_Lab2_Nhom4_Slides.pptx
@@ -519,7 +519,7 @@
           <a:p/>
           <a:p>
             <a:r>
-              <a:t>Kính chào thầy và các bạn, hôm nay Nhóm 4 xin đại diện trình bày đề tài EXE Team Matching. Ứng dụng ra đời nhằm giải quyết bài toán tìm đồng đội đa ngành có cùng mức cam kết trước hạn chót của nhà trường.</a:t>
+              <a:t>Kính chào thầy và các bạn, hôm nay Nhóm 4 xin đại diện trình bày đề tài EXE Team Matching. Ứng dụng giải quyết bài toán tìm đồng đội đa ngành có cùng mức cam kết trước hạn chót của nhà trường.</a:t>
             </a:r>
           </a:p>
         </p:txBody>
@@ -4412,18 +4412,18 @@
         </p:nvSpPr>
         <p:spPr>
           <a:xfrm>
-            <a:off x="731520" y="365760"/>
-            <a:ext cx="10728655" cy="1005840"/>
+            <a:off x="548640" y="320040"/>
+            <a:ext cx="11094415" cy="960120"/>
           </a:xfrm>
           <a:prstGeom prst="roundRect">
             <a:avLst/>
           </a:prstGeom>
           <a:solidFill>
-            <a:srgbClr val="161E31"/>
+            <a:srgbClr val="131A2A"/>
           </a:solidFill>
           <a:ln>
             <a:solidFill>
-              <a:srgbClr val="2D3748"/>
+              <a:srgbClr val="28344B"/>
             </a:solidFill>
           </a:ln>
         </p:spPr>
@@ -4454,7 +4454,7 @@
               </a:defRPr>
             </a:pPr>
             <a:r>
-              <a:t>01 / 12  ·  PROJECT OVERVIEW</a:t>
+              <a:t>01  ·  PROJECT OVERVIEW</a:t>
             </a:r>
           </a:p>
           <a:p>
@@ -4470,7 +4470,7 @@
               </a:defRPr>
             </a:pPr>
             <a:r>
-              <a:t>Hệ thống Ghép nhóm Khởi nghiệp (EXE Team Matching)</a:t>
+              <a:t>EXE Team Matching · Hệ thống Ghép nhóm Khởi nghiệp</a:t>
             </a:r>
           </a:p>
         </p:txBody>
@@ -4483,8 +4483,8 @@
         </p:nvSpPr>
         <p:spPr>
           <a:xfrm>
-            <a:off x="7772400" y="438912"/>
-            <a:ext cx="3474720" cy="457200"/>
+            <a:off x="7772400" y="384048"/>
+            <a:ext cx="3657600" cy="457200"/>
           </a:xfrm>
           <a:prstGeom prst="rect">
             <a:avLst/>
@@ -4519,18 +4519,18 @@
         </p:nvSpPr>
         <p:spPr>
           <a:xfrm>
-            <a:off x="731520" y="1508760"/>
-            <a:ext cx="6949440" cy="1554480"/>
+            <a:off x="548640" y="1417320"/>
+            <a:ext cx="8046720" cy="1584960"/>
           </a:xfrm>
           <a:prstGeom prst="roundRect">
             <a:avLst/>
           </a:prstGeom>
           <a:solidFill>
-            <a:srgbClr val="161E31"/>
+            <a:srgbClr val="131A2A"/>
           </a:solidFill>
           <a:ln>
             <a:solidFill>
-              <a:srgbClr val="2D3748"/>
+              <a:srgbClr val="28344B"/>
             </a:solidFill>
           </a:ln>
         </p:spPr>
@@ -4549,14 +4549,14 @@
           </a:fontRef>
         </p:style>
         <p:txBody>
-          <a:bodyPr rtlCol="0" anchor="ctr" lIns="228600" tIns="164592" rIns="228600" wrap="square"/>
+          <a:bodyPr rtlCol="0" anchor="ctr" lIns="228600" tIns="137160" rIns="228600" wrap="square"/>
           <a:lstStyle/>
           <a:p>
             <a:pPr algn="ctr">
               <a:spcAft>
-                <a:spcPts val="400"/>
-              </a:spcAft>
-              <a:defRPr sz="1300" b="1">
+                <a:spcPts val="300"/>
+              </a:spcAft>
+              <a:defRPr sz="1250" b="1">
                 <a:solidFill>
                   <a:srgbClr val="38BDF8"/>
                 </a:solidFill>
@@ -4572,7 +4572,7 @@
               <a:spcAft>
                 <a:spcPts val="200"/>
               </a:spcAft>
-              <a:defRPr sz="1150">
+              <a:defRPr sz="1100">
                 <a:solidFill>
                   <a:srgbClr val="E2E8F0"/>
                 </a:solidFill>
@@ -4580,7 +4580,7 @@
               </a:defRPr>
             </a:pPr>
             <a:r>
-              <a:t>• Sinh viên học EXE101/201 bắt buộc phải lập nhóm đa ngành (IT + Kinh tế/Marketing).</a:t>
+              <a:t>• Sinh viên học môn EXE101/201 bắt buộc phải lập nhóm liên ngành (IT + Kinh tế/Marketing).</a:t>
             </a:r>
           </a:p>
           <a:p>
@@ -4588,7 +4588,7 @@
               <a:spcAft>
                 <a:spcPts val="200"/>
               </a:spcAft>
-              <a:defRPr sz="1150">
+              <a:defRPr sz="1100">
                 <a:solidFill>
                   <a:srgbClr val="E2E8F0"/>
                 </a:solidFill>
@@ -4596,7 +4596,7 @@
               </a:defRPr>
             </a:pPr>
             <a:r>
-              <a:t>• Tìm nhóm qua mạng xã hội rất hỗn loạn: bài trôi nhanh, không rõ kỹ năng, dễ gặp người thiếu cam kết (free-rider).</a:t>
+              <a:t>• Tìm nhóm qua mạng xã hội rất hỗn loạn: bài trôi nhanh, kỹ năng mập mờ, dễ gặp free-rider.</a:t>
             </a:r>
           </a:p>
         </p:txBody>
@@ -4609,18 +4609,18 @@
         </p:nvSpPr>
         <p:spPr>
           <a:xfrm>
-            <a:off x="731520" y="3182112"/>
-            <a:ext cx="6949440" cy="1554480"/>
+            <a:off x="548640" y="3139440"/>
+            <a:ext cx="8046720" cy="1584960"/>
           </a:xfrm>
           <a:prstGeom prst="roundRect">
             <a:avLst/>
           </a:prstGeom>
           <a:solidFill>
-            <a:srgbClr val="161E31"/>
+            <a:srgbClr val="131A2A"/>
           </a:solidFill>
           <a:ln>
             <a:solidFill>
-              <a:srgbClr val="2D3748"/>
+              <a:srgbClr val="28344B"/>
             </a:solidFill>
           </a:ln>
         </p:spPr>
@@ -4639,14 +4639,14 @@
           </a:fontRef>
         </p:style>
         <p:txBody>
-          <a:bodyPr rtlCol="0" anchor="ctr" lIns="228600" tIns="164592" rIns="228600" wrap="square"/>
+          <a:bodyPr rtlCol="0" anchor="ctr" lIns="228600" tIns="137160" rIns="228600" wrap="square"/>
           <a:lstStyle/>
           <a:p>
             <a:pPr algn="ctr">
               <a:spcAft>
-                <a:spcPts val="400"/>
-              </a:spcAft>
-              <a:defRPr sz="1300" b="1">
+                <a:spcPts val="300"/>
+              </a:spcAft>
+              <a:defRPr sz="1250" b="1">
                 <a:solidFill>
                   <a:srgbClr val="34D399"/>
                 </a:solidFill>
@@ -4662,7 +4662,7 @@
               <a:spcAft>
                 <a:spcPts val="200"/>
               </a:spcAft>
-              <a:defRPr sz="1150">
+              <a:defRPr sz="1100">
                 <a:solidFill>
                   <a:srgbClr val="E2E8F0"/>
                 </a:solidFill>
@@ -4678,7 +4678,7 @@
               <a:spcAft>
                 <a:spcPts val="200"/>
               </a:spcAft>
-              <a:defRPr sz="1150">
+              <a:defRPr sz="1100">
                 <a:solidFill>
                   <a:srgbClr val="E2E8F0"/>
                 </a:solidFill>
@@ -4686,7 +4686,7 @@
               </a:defRPr>
             </a:pPr>
             <a:r>
-              <a:t>• Đạt mục tiêu tìm kiếm và ứng tuyển thành công chỉ trong vòng dưới 60 giây.</a:t>
+              <a:t>• Tối ưu hóa hành trình: Tìm và nộp đơn thành công chỉ trong vòng dưới 60 giây.</a:t>
             </a:r>
           </a:p>
         </p:txBody>
@@ -4699,18 +4699,18 @@
         </p:nvSpPr>
         <p:spPr>
           <a:xfrm>
-            <a:off x="731520" y="4855464"/>
-            <a:ext cx="6949440" cy="1554480"/>
+            <a:off x="548640" y="4861560"/>
+            <a:ext cx="8046720" cy="1584960"/>
           </a:xfrm>
           <a:prstGeom prst="roundRect">
             <a:avLst/>
           </a:prstGeom>
           <a:solidFill>
-            <a:srgbClr val="161E31"/>
+            <a:srgbClr val="131A2A"/>
           </a:solidFill>
           <a:ln>
             <a:solidFill>
-              <a:srgbClr val="2D3748"/>
+              <a:srgbClr val="28344B"/>
             </a:solidFill>
           </a:ln>
         </p:spPr>
@@ -4729,14 +4729,14 @@
           </a:fontRef>
         </p:style>
         <p:txBody>
-          <a:bodyPr rtlCol="0" anchor="ctr" lIns="228600" tIns="164592" rIns="228600" wrap="square"/>
+          <a:bodyPr rtlCol="0" anchor="ctr" lIns="228600" tIns="137160" rIns="228600" wrap="square"/>
           <a:lstStyle/>
           <a:p>
             <a:pPr algn="ctr">
               <a:spcAft>
-                <a:spcPts val="400"/>
-              </a:spcAft>
-              <a:defRPr sz="1300" b="1">
+                <a:spcPts val="300"/>
+              </a:spcAft>
+              <a:defRPr sz="1250" b="1">
                 <a:solidFill>
                   <a:srgbClr val="38BDF8"/>
                 </a:solidFill>
@@ -4744,7 +4744,7 @@
               </a:defRPr>
             </a:pPr>
             <a:r>
-              <a:t>👥 Đội ngũ Nhóm 4 &amp; Phân vai</a:t>
+              <a:t>👥 Đội ngũ Nhóm 4</a:t>
             </a:r>
           </a:p>
           <a:p>
@@ -4752,15 +4752,15 @@
               <a:spcAft>
                 <a:spcPts val="200"/>
               </a:spcAft>
-              <a:defRPr sz="1150">
-                <a:solidFill>
-                  <a:srgbClr val="94A3B8"/>
-                </a:solidFill>
-                <a:latin typeface="Arial"/>
-              </a:defRPr>
-            </a:pPr>
-            <a:r>
-              <a:t>• 1. Tăng Mình Trọng: Trưởng nhóm · UX Persona &amp; Sitemap</a:t>
+              <a:defRPr sz="1100">
+                <a:solidFill>
+                  <a:srgbClr val="E2E8F0"/>
+                </a:solidFill>
+                <a:latin typeface="Arial"/>
+              </a:defRPr>
+            </a:pPr>
+            <a:r>
+              <a:t>• 1. Tăng Mình Trọng: Trưởng nhóm · UX Research, Persona, Quản phối</a:t>
             </a:r>
           </a:p>
           <a:p>
@@ -4768,15 +4768,15 @@
               <a:spcAft>
                 <a:spcPts val="200"/>
               </a:spcAft>
-              <a:defRPr sz="1150">
-                <a:solidFill>
-                  <a:srgbClr val="94A3B8"/>
-                </a:solidFill>
-                <a:latin typeface="Arial"/>
-              </a:defRPr>
-            </a:pPr>
-            <a:r>
-              <a:t>• 2. Phan Anh Tuấn: User Flows, AI Prompting &amp; Heuristics</a:t>
+              <a:defRPr sz="1100">
+                <a:solidFill>
+                  <a:srgbClr val="E2E8F0"/>
+                </a:solidFill>
+                <a:latin typeface="Arial"/>
+              </a:defRPr>
+            </a:pPr>
+            <a:r>
+              <a:t>• 2. Phan Anh Tuấn: User Flows, AI Prompting &amp; Usability Heuristics</a:t>
             </a:r>
           </a:p>
           <a:p>
@@ -4784,15 +4784,15 @@
               <a:spcAft>
                 <a:spcPts val="200"/>
               </a:spcAft>
-              <a:defRPr sz="1150">
-                <a:solidFill>
-                  <a:srgbClr val="94A3B8"/>
-                </a:solidFill>
-                <a:latin typeface="Arial"/>
-              </a:defRPr>
-            </a:pPr>
-            <a:r>
-              <a:t>• 3. Đỗ Anh Minh: Design System &amp; 9 Components</a:t>
+              <a:defRPr sz="1100">
+                <a:solidFill>
+                  <a:srgbClr val="E2E8F0"/>
+                </a:solidFill>
+                <a:latin typeface="Arial"/>
+              </a:defRPr>
+            </a:pPr>
+            <a:r>
+              <a:t>• 3. Đỗ Anh Minh: Design System, Figma Components &amp; UI Audit</a:t>
             </a:r>
           </a:p>
           <a:p>
@@ -4800,15 +4800,15 @@
               <a:spcAft>
                 <a:spcPts val="200"/>
               </a:spcAft>
-              <a:defRPr sz="1150">
-                <a:solidFill>
-                  <a:srgbClr val="94A3B8"/>
-                </a:solidFill>
-                <a:latin typeface="Arial"/>
-              </a:defRPr>
-            </a:pPr>
-            <a:r>
-              <a:t>• 4. Lữ Phước Nhật Tú: Prototype &amp; Flutter Handoff</a:t>
+              <a:defRPr sz="1100">
+                <a:solidFill>
+                  <a:srgbClr val="E2E8F0"/>
+                </a:solidFill>
+                <a:latin typeface="Arial"/>
+              </a:defRPr>
+            </a:pPr>
+            <a:r>
+              <a:t>• 4. Lữ Phước Nhật Tú: Interactive Prototype &amp; Flutter Handoff</a:t>
             </a:r>
           </a:p>
         </p:txBody>
@@ -4821,18 +4821,18 @@
         </p:nvSpPr>
         <p:spPr>
           <a:xfrm>
-            <a:off x="7863840" y="1508760"/>
-            <a:ext cx="3596335" cy="4901184"/>
+            <a:off x="8778240" y="1417320"/>
+            <a:ext cx="2864815" cy="5029200"/>
           </a:xfrm>
           <a:prstGeom prst="roundRect">
             <a:avLst/>
           </a:prstGeom>
           <a:solidFill>
-            <a:srgbClr val="161E31"/>
+            <a:srgbClr val="131A2A"/>
           </a:solidFill>
           <a:ln>
             <a:solidFill>
-              <a:srgbClr val="2D3748"/>
+              <a:srgbClr val="28344B"/>
             </a:solidFill>
           </a:ln>
         </p:spPr>
@@ -4874,8 +4874,8 @@
         </p:blipFill>
         <p:spPr>
           <a:xfrm>
-            <a:off x="8092440" y="1691640"/>
-            <a:ext cx="3139135" cy="14098571"/>
+            <a:off x="9681295" y="1554480"/>
+            <a:ext cx="1058703" cy="4754880"/>
           </a:xfrm>
           <a:prstGeom prst="rect">
             <a:avLst/>
@@ -4951,18 +4951,18 @@
         </p:nvSpPr>
         <p:spPr>
           <a:xfrm>
-            <a:off x="731520" y="365760"/>
-            <a:ext cx="10728655" cy="1005840"/>
+            <a:off x="548640" y="320040"/>
+            <a:ext cx="11094415" cy="960120"/>
           </a:xfrm>
           <a:prstGeom prst="roundRect">
             <a:avLst/>
           </a:prstGeom>
           <a:solidFill>
-            <a:srgbClr val="161E31"/>
+            <a:srgbClr val="131A2A"/>
           </a:solidFill>
           <a:ln>
             <a:solidFill>
-              <a:srgbClr val="2D3748"/>
+              <a:srgbClr val="28344B"/>
             </a:solidFill>
           </a:ln>
         </p:spPr>
@@ -4993,7 +4993,7 @@
               </a:defRPr>
             </a:pPr>
             <a:r>
-              <a:t>10 / 12  ·  ACCESSIBILITY &amp; RESPONSIVE</a:t>
+              <a:t>10  ·  ACCESSIBILITY &amp; RESPONSIVE</a:t>
             </a:r>
           </a:p>
           <a:p>
@@ -5009,7 +5009,7 @@
               </a:defRPr>
             </a:pPr>
             <a:r>
-              <a:t>Kiểm chuẩn WCAG 2.1 AA &amp; Thích ứng Responsive</a:t>
+              <a:t>Kiểm chuẩn Trợ năng WCAG 2.1 AA &amp; Thích ứng Đa thiết bị</a:t>
             </a:r>
           </a:p>
         </p:txBody>
@@ -5022,8 +5022,8 @@
         </p:nvSpPr>
         <p:spPr>
           <a:xfrm>
-            <a:off x="7772400" y="438912"/>
-            <a:ext cx="3474720" cy="457200"/>
+            <a:off x="7772400" y="384048"/>
+            <a:ext cx="3657600" cy="457200"/>
           </a:xfrm>
           <a:prstGeom prst="rect">
             <a:avLst/>
@@ -5058,18 +5058,18 @@
         </p:nvSpPr>
         <p:spPr>
           <a:xfrm>
-            <a:off x="731520" y="1508760"/>
-            <a:ext cx="6949440" cy="1554480"/>
+            <a:off x="548640" y="1417320"/>
+            <a:ext cx="8046720" cy="1584960"/>
           </a:xfrm>
           <a:prstGeom prst="roundRect">
             <a:avLst/>
           </a:prstGeom>
           <a:solidFill>
-            <a:srgbClr val="161E31"/>
+            <a:srgbClr val="131A2A"/>
           </a:solidFill>
           <a:ln>
             <a:solidFill>
-              <a:srgbClr val="2D3748"/>
+              <a:srgbClr val="28344B"/>
             </a:solidFill>
           </a:ln>
         </p:spPr>
@@ -5088,16 +5088,16 @@
           </a:fontRef>
         </p:style>
         <p:txBody>
-          <a:bodyPr rtlCol="0" anchor="ctr" lIns="228600" tIns="164592" rIns="228600" wrap="square"/>
+          <a:bodyPr rtlCol="0" anchor="ctr" lIns="228600" tIns="137160" rIns="228600" wrap="square"/>
           <a:lstStyle/>
           <a:p>
             <a:pPr algn="ctr">
               <a:spcAft>
-                <a:spcPts val="400"/>
-              </a:spcAft>
-              <a:defRPr sz="1300" b="1">
-                <a:solidFill>
-                  <a:srgbClr val="38BDF8"/>
+                <a:spcPts val="300"/>
+              </a:spcAft>
+              <a:defRPr sz="1250" b="1">
+                <a:solidFill>
+                  <a:srgbClr val="34D399"/>
                 </a:solidFill>
                 <a:latin typeface="Arial"/>
               </a:defRPr>
@@ -5111,7 +5111,7 @@
               <a:spcAft>
                 <a:spcPts val="200"/>
               </a:spcAft>
-              <a:defRPr sz="1150">
+              <a:defRPr sz="1100">
                 <a:solidFill>
                   <a:srgbClr val="E2E8F0"/>
                 </a:solidFill>
@@ -5127,7 +5127,7 @@
               <a:spcAft>
                 <a:spcPts val="200"/>
               </a:spcAft>
-              <a:defRPr sz="1150">
+              <a:defRPr sz="1100">
                 <a:solidFill>
                   <a:srgbClr val="E2E8F0"/>
                 </a:solidFill>
@@ -5143,7 +5143,7 @@
               <a:spcAft>
                 <a:spcPts val="200"/>
               </a:spcAft>
-              <a:defRPr sz="1150">
+              <a:defRPr sz="1100">
                 <a:solidFill>
                   <a:srgbClr val="E2E8F0"/>
                 </a:solidFill>
@@ -5159,7 +5159,7 @@
               <a:spcAft>
                 <a:spcPts val="200"/>
               </a:spcAft>
-              <a:defRPr sz="1150">
+              <a:defRPr sz="1100">
                 <a:solidFill>
                   <a:srgbClr val="E2E8F0"/>
                 </a:solidFill>
@@ -5180,18 +5180,18 @@
         </p:nvSpPr>
         <p:spPr>
           <a:xfrm>
-            <a:off x="731520" y="3182112"/>
-            <a:ext cx="6949440" cy="1554480"/>
+            <a:off x="548640" y="3139440"/>
+            <a:ext cx="8046720" cy="1584960"/>
           </a:xfrm>
           <a:prstGeom prst="roundRect">
             <a:avLst/>
           </a:prstGeom>
           <a:solidFill>
-            <a:srgbClr val="161E31"/>
+            <a:srgbClr val="131A2A"/>
           </a:solidFill>
           <a:ln>
             <a:solidFill>
-              <a:srgbClr val="2D3748"/>
+              <a:srgbClr val="28344B"/>
             </a:solidFill>
           </a:ln>
         </p:spPr>
@@ -5210,22 +5210,22 @@
           </a:fontRef>
         </p:style>
         <p:txBody>
-          <a:bodyPr rtlCol="0" anchor="ctr" lIns="228600" tIns="164592" rIns="228600" wrap="square"/>
+          <a:bodyPr rtlCol="0" anchor="ctr" lIns="228600" tIns="137160" rIns="228600" wrap="square"/>
           <a:lstStyle/>
           <a:p>
             <a:pPr algn="ctr">
               <a:spcAft>
-                <a:spcPts val="400"/>
-              </a:spcAft>
-              <a:defRPr sz="1300" b="1">
-                <a:solidFill>
-                  <a:srgbClr val="34D399"/>
-                </a:solidFill>
-                <a:latin typeface="Arial"/>
-              </a:defRPr>
-            </a:pPr>
-            <a:r>
-              <a:t>📱 Thích ứng Màn hình Đa kích thước</a:t>
+                <a:spcPts val="300"/>
+              </a:spcAft>
+              <a:defRPr sz="1250" b="1">
+                <a:solidFill>
+                  <a:srgbClr val="38BDF8"/>
+                </a:solidFill>
+                <a:latin typeface="Arial"/>
+              </a:defRPr>
+            </a:pPr>
+            <a:r>
+              <a:t>📱 Thích ứng Màn hình Đa kích thước (Responsive)</a:t>
             </a:r>
           </a:p>
           <a:p>
@@ -5233,7 +5233,7 @@
               <a:spcAft>
                 <a:spcPts val="200"/>
               </a:spcAft>
-              <a:defRPr sz="1150">
+              <a:defRPr sz="1100">
                 <a:solidFill>
                   <a:srgbClr val="E2E8F0"/>
                 </a:solidFill>
@@ -5249,7 +5249,7 @@
               <a:spcAft>
                 <a:spcPts val="200"/>
               </a:spcAft>
-              <a:defRPr sz="1150">
+              <a:defRPr sz="1100">
                 <a:solidFill>
                   <a:srgbClr val="E2E8F0"/>
                 </a:solidFill>
@@ -5257,7 +5257,7 @@
               </a:defRPr>
             </a:pPr>
             <a:r>
-              <a:t>• Tự động co giãn không vỡ khung trên màn hình lớn 412x915 dp nhờ thiết lập Auto Layout 'Fill container'.</a:t>
+              <a:t>• Tự động co giãn không vỡ khung trên màn hình lớn 412x915 dp nhờ Auto Layout 'Fill container'.</a:t>
             </a:r>
           </a:p>
         </p:txBody>
@@ -5270,18 +5270,18 @@
         </p:nvSpPr>
         <p:spPr>
           <a:xfrm>
-            <a:off x="731520" y="4855464"/>
-            <a:ext cx="6949440" cy="1554480"/>
+            <a:off x="548640" y="4861560"/>
+            <a:ext cx="8046720" cy="1584960"/>
           </a:xfrm>
           <a:prstGeom prst="roundRect">
             <a:avLst/>
           </a:prstGeom>
           <a:solidFill>
-            <a:srgbClr val="161E31"/>
+            <a:srgbClr val="131A2A"/>
           </a:solidFill>
           <a:ln>
             <a:solidFill>
-              <a:srgbClr val="2D3748"/>
+              <a:srgbClr val="28344B"/>
             </a:solidFill>
           </a:ln>
         </p:spPr>
@@ -5300,16 +5300,16 @@
           </a:fontRef>
         </p:style>
         <p:txBody>
-          <a:bodyPr rtlCol="0" anchor="ctr" lIns="228600" tIns="164592" rIns="228600" wrap="square"/>
+          <a:bodyPr rtlCol="0" anchor="ctr" lIns="228600" tIns="137160" rIns="228600" wrap="square"/>
           <a:lstStyle/>
           <a:p>
             <a:pPr algn="ctr">
               <a:spcAft>
-                <a:spcPts val="400"/>
-              </a:spcAft>
-              <a:defRPr sz="1300" b="1">
-                <a:solidFill>
-                  <a:srgbClr val="38BDF8"/>
+                <a:spcPts val="300"/>
+              </a:spcAft>
+              <a:defRPr sz="1250" b="1">
+                <a:solidFill>
+                  <a:srgbClr val="34D399"/>
                 </a:solidFill>
                 <a:latin typeface="Arial"/>
               </a:defRPr>
@@ -5323,15 +5323,15 @@
               <a:spcAft>
                 <a:spcPts val="200"/>
               </a:spcAft>
-              <a:defRPr sz="1150">
-                <a:solidFill>
-                  <a:srgbClr val="94A3B8"/>
-                </a:solidFill>
-                <a:latin typeface="Arial"/>
-              </a:defRPr>
-            </a:pPr>
-            <a:r>
-              <a:t>• Bảng kiểm định tương phản tại design/design-decisions.md.</a:t>
+              <a:defRPr sz="1100">
+                <a:solidFill>
+                  <a:srgbClr val="E2E8F0"/>
+                </a:solidFill>
+                <a:latin typeface="Arial"/>
+              </a:defRPr>
+            </a:pPr>
+            <a:r>
+              <a:t>• Xem bảng kiểm định chi tiết tại file design/design-decisions.md.</a:t>
             </a:r>
           </a:p>
         </p:txBody>
@@ -5344,18 +5344,18 @@
         </p:nvSpPr>
         <p:spPr>
           <a:xfrm>
-            <a:off x="7863840" y="1508760"/>
-            <a:ext cx="3596335" cy="4901184"/>
+            <a:off x="8778240" y="1417320"/>
+            <a:ext cx="2864815" cy="5029200"/>
           </a:xfrm>
           <a:prstGeom prst="roundRect">
             <a:avLst/>
           </a:prstGeom>
           <a:solidFill>
-            <a:srgbClr val="161E31"/>
+            <a:srgbClr val="131A2A"/>
           </a:solidFill>
           <a:ln>
             <a:solidFill>
-              <a:srgbClr val="2D3748"/>
+              <a:srgbClr val="28344B"/>
             </a:solidFill>
           </a:ln>
         </p:spPr>
@@ -5397,8 +5397,8 @@
         </p:blipFill>
         <p:spPr>
           <a:xfrm>
-            <a:off x="8092440" y="1691640"/>
-            <a:ext cx="3139135" cy="7127437"/>
+            <a:off x="9163552" y="1554480"/>
+            <a:ext cx="2094190" cy="4754880"/>
           </a:xfrm>
           <a:prstGeom prst="rect">
             <a:avLst/>
@@ -5474,18 +5474,18 @@
         </p:nvSpPr>
         <p:spPr>
           <a:xfrm>
-            <a:off x="731520" y="365760"/>
-            <a:ext cx="10728655" cy="1005840"/>
+            <a:off x="548640" y="320040"/>
+            <a:ext cx="11094415" cy="960120"/>
           </a:xfrm>
           <a:prstGeom prst="roundRect">
             <a:avLst/>
           </a:prstGeom>
           <a:solidFill>
-            <a:srgbClr val="161E31"/>
+            <a:srgbClr val="131A2A"/>
           </a:solidFill>
           <a:ln>
             <a:solidFill>
-              <a:srgbClr val="2D3748"/>
+              <a:srgbClr val="28344B"/>
             </a:solidFill>
           </a:ln>
         </p:spPr>
@@ -5516,7 +5516,7 @@
               </a:defRPr>
             </a:pPr>
             <a:r>
-              <a:t>11 / 12  ·  LIVE PROTOTYPE</a:t>
+              <a:t>11  ·  LIVE PROTOTYPE</a:t>
             </a:r>
           </a:p>
           <a:p>
@@ -5532,7 +5532,7 @@
               </a:defRPr>
             </a:pPr>
             <a:r>
-              <a:t>Nguyên mẫu Tương tác Figma (Figma Page 06)</a:t>
+              <a:t>Nguyên mẫu Tương tác Figma · Khép kín Không Ngõ Cụt</a:t>
             </a:r>
           </a:p>
         </p:txBody>
@@ -5545,8 +5545,8 @@
         </p:nvSpPr>
         <p:spPr>
           <a:xfrm>
-            <a:off x="7772400" y="438912"/>
-            <a:ext cx="3474720" cy="457200"/>
+            <a:off x="7772400" y="384048"/>
+            <a:ext cx="3657600" cy="457200"/>
           </a:xfrm>
           <a:prstGeom prst="rect">
             <a:avLst/>
@@ -5581,18 +5581,18 @@
         </p:nvSpPr>
         <p:spPr>
           <a:xfrm>
-            <a:off x="731520" y="1508760"/>
-            <a:ext cx="6949440" cy="1554480"/>
+            <a:off x="548640" y="1417320"/>
+            <a:ext cx="8046720" cy="1584960"/>
           </a:xfrm>
           <a:prstGeom prst="roundRect">
             <a:avLst/>
           </a:prstGeom>
           <a:solidFill>
-            <a:srgbClr val="161E31"/>
+            <a:srgbClr val="131A2A"/>
           </a:solidFill>
           <a:ln>
             <a:solidFill>
-              <a:srgbClr val="2D3748"/>
+              <a:srgbClr val="28344B"/>
             </a:solidFill>
           </a:ln>
         </p:spPr>
@@ -5611,14 +5611,14 @@
           </a:fontRef>
         </p:style>
         <p:txBody>
-          <a:bodyPr rtlCol="0" anchor="ctr" lIns="228600" tIns="164592" rIns="228600" wrap="square"/>
+          <a:bodyPr rtlCol="0" anchor="ctr" lIns="228600" tIns="137160" rIns="228600" wrap="square"/>
           <a:lstStyle/>
           <a:p>
             <a:pPr algn="ctr">
               <a:spcAft>
-                <a:spcPts val="400"/>
-              </a:spcAft>
-              <a:defRPr sz="1300" b="1">
+                <a:spcPts val="300"/>
+              </a:spcAft>
+              <a:defRPr sz="1250" b="1">
                 <a:solidFill>
                   <a:srgbClr val="38BDF8"/>
                 </a:solidFill>
@@ -5634,7 +5634,7 @@
               <a:spcAft>
                 <a:spcPts val="200"/>
               </a:spcAft>
-              <a:defRPr sz="1150">
+              <a:defRPr sz="1100">
                 <a:solidFill>
                   <a:srgbClr val="E2E8F0"/>
                 </a:solidFill>
@@ -5650,7 +5650,7 @@
               <a:spcAft>
                 <a:spcPts val="200"/>
               </a:spcAft>
-              <a:defRPr sz="1150">
+              <a:defRPr sz="1100">
                 <a:solidFill>
                   <a:srgbClr val="E2E8F0"/>
                 </a:solidFill>
@@ -5666,7 +5666,7 @@
               <a:spcAft>
                 <a:spcPts val="200"/>
               </a:spcAft>
-              <a:defRPr sz="1150">
+              <a:defRPr sz="1100">
                 <a:solidFill>
                   <a:srgbClr val="E2E8F0"/>
                 </a:solidFill>
@@ -5687,18 +5687,18 @@
         </p:nvSpPr>
         <p:spPr>
           <a:xfrm>
-            <a:off x="731520" y="3182112"/>
-            <a:ext cx="6949440" cy="1554480"/>
+            <a:off x="548640" y="3139440"/>
+            <a:ext cx="8046720" cy="1584960"/>
           </a:xfrm>
           <a:prstGeom prst="roundRect">
             <a:avLst/>
           </a:prstGeom>
           <a:solidFill>
-            <a:srgbClr val="161E31"/>
+            <a:srgbClr val="131A2A"/>
           </a:solidFill>
           <a:ln>
             <a:solidFill>
-              <a:srgbClr val="2D3748"/>
+              <a:srgbClr val="28344B"/>
             </a:solidFill>
           </a:ln>
         </p:spPr>
@@ -5717,14 +5717,14 @@
           </a:fontRef>
         </p:style>
         <p:txBody>
-          <a:bodyPr rtlCol="0" anchor="ctr" lIns="228600" tIns="164592" rIns="228600" wrap="square"/>
+          <a:bodyPr rtlCol="0" anchor="ctr" lIns="228600" tIns="137160" rIns="228600" wrap="square"/>
           <a:lstStyle/>
           <a:p>
             <a:pPr algn="ctr">
               <a:spcAft>
-                <a:spcPts val="400"/>
-              </a:spcAft>
-              <a:defRPr sz="1300" b="1">
+                <a:spcPts val="300"/>
+              </a:spcAft>
+              <a:defRPr sz="1250" b="1">
                 <a:solidFill>
                   <a:srgbClr val="34D399"/>
                 </a:solidFill>
@@ -5740,7 +5740,7 @@
               <a:spcAft>
                 <a:spcPts val="200"/>
               </a:spcAft>
-              <a:defRPr sz="1150">
+              <a:defRPr sz="1100">
                 <a:solidFill>
                   <a:srgbClr val="E2E8F0"/>
                 </a:solidFill>
@@ -5756,7 +5756,7 @@
               <a:spcAft>
                 <a:spcPts val="200"/>
               </a:spcAft>
-              <a:defRPr sz="1150">
+              <a:defRPr sz="1100">
                 <a:solidFill>
                   <a:srgbClr val="E2E8F0"/>
                 </a:solidFill>
@@ -5764,7 +5764,7 @@
               </a:defRPr>
             </a:pPr>
             <a:r>
-              <a:t>• Nút 'Về trang chủ' và 'Xem đơn' sau khi nộp đơn giúp loại bỏ hoàn toàn bẫy ngõ cụt.</a:t>
+              <a:t>• Nút 'Về trang chủ' và 'Xem đơn' sau khi nộp đơn loại bỏ hoàn toàn bẫy ngõ cụt.</a:t>
             </a:r>
           </a:p>
           <a:p>
@@ -5772,7 +5772,7 @@
               <a:spcAft>
                 <a:spcPts val="200"/>
               </a:spcAft>
-              <a:defRPr sz="1150">
+              <a:defRPr sz="1100">
                 <a:solidFill>
                   <a:srgbClr val="E2E8F0"/>
                 </a:solidFill>
@@ -5793,18 +5793,18 @@
         </p:nvSpPr>
         <p:spPr>
           <a:xfrm>
-            <a:off x="731520" y="4855464"/>
-            <a:ext cx="6949440" cy="1554480"/>
+            <a:off x="548640" y="4861560"/>
+            <a:ext cx="8046720" cy="1584960"/>
           </a:xfrm>
           <a:prstGeom prst="roundRect">
             <a:avLst/>
           </a:prstGeom>
           <a:solidFill>
-            <a:srgbClr val="161E31"/>
+            <a:srgbClr val="131A2A"/>
           </a:solidFill>
           <a:ln>
             <a:solidFill>
-              <a:srgbClr val="2D3748"/>
+              <a:srgbClr val="28344B"/>
             </a:solidFill>
           </a:ln>
         </p:spPr>
@@ -5823,14 +5823,14 @@
           </a:fontRef>
         </p:style>
         <p:txBody>
-          <a:bodyPr rtlCol="0" anchor="ctr" lIns="228600" tIns="164592" rIns="228600" wrap="square"/>
+          <a:bodyPr rtlCol="0" anchor="ctr" lIns="228600" tIns="137160" rIns="228600" wrap="square"/>
           <a:lstStyle/>
           <a:p>
             <a:pPr algn="ctr">
               <a:spcAft>
-                <a:spcPts val="400"/>
-              </a:spcAft>
-              <a:defRPr sz="1300" b="1">
+                <a:spcPts val="300"/>
+              </a:spcAft>
+              <a:defRPr sz="1250" b="1">
                 <a:solidFill>
                   <a:srgbClr val="38BDF8"/>
                 </a:solidFill>
@@ -5846,15 +5846,15 @@
               <a:spcAft>
                 <a:spcPts val="200"/>
               </a:spcAft>
-              <a:defRPr sz="1150">
-                <a:solidFill>
-                  <a:srgbClr val="94A3B8"/>
-                </a:solidFill>
-                <a:latin typeface="Arial"/>
-              </a:defRPr>
-            </a:pPr>
-            <a:r>
-              <a:t>• Sẵn sàng cho phiên Live Demo 5 phút trên Figma Canvas.</a:t>
+              <a:defRPr sz="1100">
+                <a:solidFill>
+                  <a:srgbClr val="E2E8F0"/>
+                </a:solidFill>
+                <a:latin typeface="Arial"/>
+              </a:defRPr>
+            </a:pPr>
+            <a:r>
+              <a:t>• Sẵn sàng cho phiên Live Demo 5 phút trực tiếp trên Figma Canvas.</a:t>
             </a:r>
           </a:p>
         </p:txBody>
@@ -5867,18 +5867,18 @@
         </p:nvSpPr>
         <p:spPr>
           <a:xfrm>
-            <a:off x="7863840" y="1508760"/>
-            <a:ext cx="3596335" cy="4901184"/>
+            <a:off x="8778240" y="1417320"/>
+            <a:ext cx="2864815" cy="5029200"/>
           </a:xfrm>
           <a:prstGeom prst="roundRect">
             <a:avLst/>
           </a:prstGeom>
           <a:solidFill>
-            <a:srgbClr val="161E31"/>
+            <a:srgbClr val="131A2A"/>
           </a:solidFill>
           <a:ln>
             <a:solidFill>
-              <a:srgbClr val="2D3748"/>
+              <a:srgbClr val="28344B"/>
             </a:solidFill>
           </a:ln>
         </p:spPr>
@@ -5920,8 +5920,8 @@
         </p:blipFill>
         <p:spPr>
           <a:xfrm>
-            <a:off x="8092440" y="1691640"/>
-            <a:ext cx="3139135" cy="20474358"/>
+            <a:off x="9846137" y="1554480"/>
+            <a:ext cx="729019" cy="4754880"/>
           </a:xfrm>
           <a:prstGeom prst="rect">
             <a:avLst/>
@@ -5997,18 +5997,18 @@
         </p:nvSpPr>
         <p:spPr>
           <a:xfrm>
-            <a:off x="731520" y="365760"/>
-            <a:ext cx="10728655" cy="1005840"/>
+            <a:off x="548640" y="320040"/>
+            <a:ext cx="11094415" cy="960120"/>
           </a:xfrm>
           <a:prstGeom prst="roundRect">
             <a:avLst/>
           </a:prstGeom>
           <a:solidFill>
-            <a:srgbClr val="161E31"/>
+            <a:srgbClr val="131A2A"/>
           </a:solidFill>
           <a:ln>
             <a:solidFill>
-              <a:srgbClr val="2D3748"/>
+              <a:srgbClr val="28344B"/>
             </a:solidFill>
           </a:ln>
         </p:spPr>
@@ -6039,7 +6039,7 @@
               </a:defRPr>
             </a:pPr>
             <a:r>
-              <a:t>12 / 12  ·  FLUTTER HANDOFF &amp; SUMMARY</a:t>
+              <a:t>12  ·  FLUTTER HANDOFF &amp; SUMMARY</a:t>
             </a:r>
           </a:p>
           <a:p>
@@ -6068,8 +6068,8 @@
         </p:nvSpPr>
         <p:spPr>
           <a:xfrm>
-            <a:off x="7772400" y="438912"/>
-            <a:ext cx="3474720" cy="457200"/>
+            <a:off x="7772400" y="384048"/>
+            <a:ext cx="3657600" cy="457200"/>
           </a:xfrm>
           <a:prstGeom prst="rect">
             <a:avLst/>
@@ -6104,18 +6104,18 @@
         </p:nvSpPr>
         <p:spPr>
           <a:xfrm>
-            <a:off x="731520" y="1508760"/>
-            <a:ext cx="6949440" cy="1554480"/>
+            <a:off x="548640" y="1417320"/>
+            <a:ext cx="8046720" cy="1584960"/>
           </a:xfrm>
           <a:prstGeom prst="roundRect">
             <a:avLst/>
           </a:prstGeom>
           <a:solidFill>
-            <a:srgbClr val="161E31"/>
+            <a:srgbClr val="131A2A"/>
           </a:solidFill>
           <a:ln>
             <a:solidFill>
-              <a:srgbClr val="2D3748"/>
+              <a:srgbClr val="28344B"/>
             </a:solidFill>
           </a:ln>
         </p:spPr>
@@ -6134,14 +6134,14 @@
           </a:fontRef>
         </p:style>
         <p:txBody>
-          <a:bodyPr rtlCol="0" anchor="ctr" lIns="228600" tIns="164592" rIns="228600" wrap="square"/>
+          <a:bodyPr rtlCol="0" anchor="ctr" lIns="228600" tIns="137160" rIns="228600" wrap="square"/>
           <a:lstStyle/>
           <a:p>
             <a:pPr algn="ctr">
               <a:spcAft>
-                <a:spcPts val="400"/>
-              </a:spcAft>
-              <a:defRPr sz="1300" b="1">
+                <a:spcPts val="300"/>
+              </a:spcAft>
+              <a:defRPr sz="1250" b="1">
                 <a:solidFill>
                   <a:srgbClr val="38BDF8"/>
                 </a:solidFill>
@@ -6157,7 +6157,7 @@
               <a:spcAft>
                 <a:spcPts val="200"/>
               </a:spcAft>
-              <a:defRPr sz="1150">
+              <a:defRPr sz="1100">
                 <a:solidFill>
                   <a:srgbClr val="E2E8F0"/>
                 </a:solidFill>
@@ -6173,7 +6173,7 @@
               <a:spcAft>
                 <a:spcPts val="200"/>
               </a:spcAft>
-              <a:defRPr sz="1150">
+              <a:defRPr sz="1100">
                 <a:solidFill>
                   <a:srgbClr val="E2E8F0"/>
                 </a:solidFill>
@@ -6189,7 +6189,7 @@
               <a:spcAft>
                 <a:spcPts val="200"/>
               </a:spcAft>
-              <a:defRPr sz="1150">
+              <a:defRPr sz="1100">
                 <a:solidFill>
                   <a:srgbClr val="E2E8F0"/>
                 </a:solidFill>
@@ -6210,18 +6210,18 @@
         </p:nvSpPr>
         <p:spPr>
           <a:xfrm>
-            <a:off x="731520" y="3182112"/>
-            <a:ext cx="6949440" cy="1554480"/>
+            <a:off x="548640" y="3139440"/>
+            <a:ext cx="8046720" cy="1584960"/>
           </a:xfrm>
           <a:prstGeom prst="roundRect">
             <a:avLst/>
           </a:prstGeom>
           <a:solidFill>
-            <a:srgbClr val="161E31"/>
+            <a:srgbClr val="131A2A"/>
           </a:solidFill>
           <a:ln>
             <a:solidFill>
-              <a:srgbClr val="2D3748"/>
+              <a:srgbClr val="28344B"/>
             </a:solidFill>
           </a:ln>
         </p:spPr>
@@ -6240,14 +6240,14 @@
           </a:fontRef>
         </p:style>
         <p:txBody>
-          <a:bodyPr rtlCol="0" anchor="ctr" lIns="228600" tIns="164592" rIns="228600" wrap="square"/>
+          <a:bodyPr rtlCol="0" anchor="ctr" lIns="228600" tIns="137160" rIns="228600" wrap="square"/>
           <a:lstStyle/>
           <a:p>
             <a:pPr algn="ctr">
               <a:spcAft>
-                <a:spcPts val="400"/>
-              </a:spcAft>
-              <a:defRPr sz="1300" b="1">
+                <a:spcPts val="300"/>
+              </a:spcAft>
+              <a:defRPr sz="1250" b="1">
                 <a:solidFill>
                   <a:srgbClr val="34D399"/>
                 </a:solidFill>
@@ -6255,7 +6255,7 @@
               </a:defRPr>
             </a:pPr>
             <a:r>
-              <a:t>🏆 Tổng kết Điểm Rubric</a:t>
+              <a:t>🏆 Tổng kết Điểm Rubric Môn học</a:t>
             </a:r>
           </a:p>
           <a:p>
@@ -6263,7 +6263,7 @@
               <a:spcAft>
                 <a:spcPts val="200"/>
               </a:spcAft>
-              <a:defRPr sz="1150">
+              <a:defRPr sz="1100">
                 <a:solidFill>
                   <a:srgbClr val="E2E8F0"/>
                 </a:solidFill>
@@ -6279,7 +6279,7 @@
               <a:spcAft>
                 <a:spcPts val="200"/>
               </a:spcAft>
-              <a:defRPr sz="1150">
+              <a:defRPr sz="1100">
                 <a:solidFill>
                   <a:srgbClr val="E2E8F0"/>
                 </a:solidFill>
@@ -6295,7 +6295,7 @@
               <a:spcAft>
                 <a:spcPts val="200"/>
               </a:spcAft>
-              <a:defRPr sz="1150">
+              <a:defRPr sz="1100">
                 <a:solidFill>
                   <a:srgbClr val="E2E8F0"/>
                 </a:solidFill>
@@ -6303,7 +6303,7 @@
               </a:defRPr>
             </a:pPr>
             <a:r>
-              <a:t>• Tổng điểm dự kiến: 100 / 100 ĐIỂM.</a:t>
+              <a:t>• TỔNG ĐIỂM DỰ KIẾN: 100 / 100 ĐIỂM.</a:t>
             </a:r>
           </a:p>
         </p:txBody>
@@ -6316,18 +6316,18 @@
         </p:nvSpPr>
         <p:spPr>
           <a:xfrm>
-            <a:off x="731520" y="4855464"/>
-            <a:ext cx="6949440" cy="1554480"/>
+            <a:off x="548640" y="4861560"/>
+            <a:ext cx="8046720" cy="1584960"/>
           </a:xfrm>
           <a:prstGeom prst="roundRect">
             <a:avLst/>
           </a:prstGeom>
           <a:solidFill>
-            <a:srgbClr val="161E31"/>
+            <a:srgbClr val="131A2A"/>
           </a:solidFill>
           <a:ln>
             <a:solidFill>
-              <a:srgbClr val="2D3748"/>
+              <a:srgbClr val="28344B"/>
             </a:solidFill>
           </a:ln>
         </p:spPr>
@@ -6346,14 +6346,14 @@
           </a:fontRef>
         </p:style>
         <p:txBody>
-          <a:bodyPr rtlCol="0" anchor="ctr" lIns="228600" tIns="164592" rIns="228600" wrap="square"/>
+          <a:bodyPr rtlCol="0" anchor="ctr" lIns="228600" tIns="137160" rIns="228600" wrap="square"/>
           <a:lstStyle/>
           <a:p>
             <a:pPr algn="ctr">
               <a:spcAft>
-                <a:spcPts val="400"/>
-              </a:spcAft>
-              <a:defRPr sz="1300" b="1">
+                <a:spcPts val="300"/>
+              </a:spcAft>
+              <a:defRPr sz="1250" b="1">
                 <a:solidFill>
                   <a:srgbClr val="38BDF8"/>
                 </a:solidFill>
@@ -6361,7 +6361,7 @@
               </a:defRPr>
             </a:pPr>
             <a:r>
-              <a:t>🔗 Liên kết Nộp bài</a:t>
+              <a:t>🔗 Liên kết Nộp bài Chính thức</a:t>
             </a:r>
           </a:p>
           <a:p>
@@ -6369,15 +6369,31 @@
               <a:spcAft>
                 <a:spcPts val="200"/>
               </a:spcAft>
-              <a:defRPr sz="1150">
-                <a:solidFill>
-                  <a:srgbClr val="94A3B8"/>
-                </a:solidFill>
-                <a:latin typeface="Arial"/>
-              </a:defRPr>
-            </a:pPr>
-            <a:r>
-              <a:t>• GitHub: github.com/LuTu-2004/prm323-lab2-group4 | Figma Public Link</a:t>
+              <a:defRPr sz="1100">
+                <a:solidFill>
+                  <a:srgbClr val="E2E8F0"/>
+                </a:solidFill>
+                <a:latin typeface="Arial"/>
+              </a:defRPr>
+            </a:pPr>
+            <a:r>
+              <a:t>• GitHub: github.com/LuTu-2004/prm323-lab2-group4</a:t>
+            </a:r>
+          </a:p>
+          <a:p>
+            <a:pPr>
+              <a:spcAft>
+                <a:spcPts val="200"/>
+              </a:spcAft>
+              <a:defRPr sz="1100">
+                <a:solidFill>
+                  <a:srgbClr val="E2E8F0"/>
+                </a:solidFill>
+                <a:latin typeface="Arial"/>
+              </a:defRPr>
+            </a:pPr>
+            <a:r>
+              <a:t>• Figma Link: Công khai quyền xem trên Canvas.</a:t>
             </a:r>
           </a:p>
         </p:txBody>
@@ -6390,18 +6406,18 @@
         </p:nvSpPr>
         <p:spPr>
           <a:xfrm>
-            <a:off x="7863840" y="1508760"/>
-            <a:ext cx="3596335" cy="4901184"/>
+            <a:off x="8778240" y="1417320"/>
+            <a:ext cx="2864815" cy="5029200"/>
           </a:xfrm>
           <a:prstGeom prst="roundRect">
             <a:avLst/>
           </a:prstGeom>
           <a:solidFill>
-            <a:srgbClr val="161E31"/>
+            <a:srgbClr val="131A2A"/>
           </a:solidFill>
           <a:ln>
             <a:solidFill>
-              <a:srgbClr val="2D3748"/>
+              <a:srgbClr val="28344B"/>
             </a:solidFill>
           </a:ln>
         </p:spPr>
@@ -6443,8 +6459,8 @@
         </p:blipFill>
         <p:spPr>
           <a:xfrm>
-            <a:off x="8092440" y="1691640"/>
-            <a:ext cx="3139135" cy="13228289"/>
+            <a:off x="9646469" y="1554480"/>
+            <a:ext cx="1128355" cy="4754880"/>
           </a:xfrm>
           <a:prstGeom prst="rect">
             <a:avLst/>
@@ -6520,18 +6536,18 @@
         </p:nvSpPr>
         <p:spPr>
           <a:xfrm>
-            <a:off x="731520" y="365760"/>
-            <a:ext cx="10728655" cy="1005840"/>
+            <a:off x="548640" y="320040"/>
+            <a:ext cx="11094415" cy="960120"/>
           </a:xfrm>
           <a:prstGeom prst="roundRect">
             <a:avLst/>
           </a:prstGeom>
           <a:solidFill>
-            <a:srgbClr val="161E31"/>
+            <a:srgbClr val="131A2A"/>
           </a:solidFill>
           <a:ln>
             <a:solidFill>
-              <a:srgbClr val="2D3748"/>
+              <a:srgbClr val="28344B"/>
             </a:solidFill>
           </a:ln>
         </p:spPr>
@@ -6562,7 +6578,7 @@
               </a:defRPr>
             </a:pPr>
             <a:r>
-              <a:t>02 / 12  ·  PROBLEM &amp; PERSONA</a:t>
+              <a:t>02  ·  PROBLEM &amp; PERSONA</a:t>
             </a:r>
           </a:p>
           <a:p>
@@ -6578,7 +6594,7 @@
               </a:defRPr>
             </a:pPr>
             <a:r>
-              <a:t>Primary Persona: Lê Quốc Huy (Tech-Savvy Active Seeker)</a:t>
+              <a:t>Primary Persona · Lê Quốc Huy (Tech-Savvy Active Seeker)</a:t>
             </a:r>
           </a:p>
         </p:txBody>
@@ -6591,8 +6607,8 @@
         </p:nvSpPr>
         <p:spPr>
           <a:xfrm>
-            <a:off x="7772400" y="438912"/>
-            <a:ext cx="3474720" cy="457200"/>
+            <a:off x="7772400" y="384048"/>
+            <a:ext cx="3657600" cy="457200"/>
           </a:xfrm>
           <a:prstGeom prst="rect">
             <a:avLst/>
@@ -6627,18 +6643,18 @@
         </p:nvSpPr>
         <p:spPr>
           <a:xfrm>
-            <a:off x="731520" y="1508760"/>
-            <a:ext cx="6949440" cy="1554480"/>
+            <a:off x="548640" y="1417320"/>
+            <a:ext cx="8046720" cy="1584960"/>
           </a:xfrm>
           <a:prstGeom prst="roundRect">
             <a:avLst/>
           </a:prstGeom>
           <a:solidFill>
-            <a:srgbClr val="161E31"/>
+            <a:srgbClr val="131A2A"/>
           </a:solidFill>
           <a:ln>
             <a:solidFill>
-              <a:srgbClr val="2D3748"/>
+              <a:srgbClr val="28344B"/>
             </a:solidFill>
           </a:ln>
         </p:spPr>
@@ -6657,14 +6673,14 @@
           </a:fontRef>
         </p:style>
         <p:txBody>
-          <a:bodyPr rtlCol="0" anchor="ctr" lIns="228600" tIns="164592" rIns="228600" wrap="square"/>
+          <a:bodyPr rtlCol="0" anchor="ctr" lIns="228600" tIns="137160" rIns="228600" wrap="square"/>
           <a:lstStyle/>
           <a:p>
             <a:pPr algn="ctr">
               <a:spcAft>
-                <a:spcPts val="400"/>
-              </a:spcAft>
-              <a:defRPr sz="1300" b="1">
+                <a:spcPts val="300"/>
+              </a:spcAft>
+              <a:defRPr sz="1250" b="1">
                 <a:solidFill>
                   <a:srgbClr val="38BDF8"/>
                 </a:solidFill>
@@ -6680,7 +6696,7 @@
               <a:spcAft>
                 <a:spcPts val="200"/>
               </a:spcAft>
-              <a:defRPr sz="1150">
+              <a:defRPr sz="1100">
                 <a:solidFill>
                   <a:srgbClr val="E2E8F0"/>
                 </a:solidFill>
@@ -6696,7 +6712,7 @@
               <a:spcAft>
                 <a:spcPts val="200"/>
               </a:spcAft>
-              <a:defRPr sz="1150">
+              <a:defRPr sz="1100">
                 <a:solidFill>
                   <a:srgbClr val="E2E8F0"/>
                 </a:solidFill>
@@ -6704,7 +6720,7 @@
               </a:defRPr>
             </a:pPr>
             <a:r>
-              <a:t>• Mục tiêu: Technical Lead / Mobile Developer.</a:t>
+              <a:t>• Vai trò: Technical Lead / Mobile App Developer.</a:t>
             </a:r>
           </a:p>
           <a:p>
@@ -6712,7 +6728,7 @@
               <a:spcAft>
                 <a:spcPts val="200"/>
               </a:spcAft>
-              <a:defRPr sz="1150">
+              <a:defRPr sz="1100">
                 <a:solidFill>
                   <a:srgbClr val="E2E8F0"/>
                 </a:solidFill>
@@ -6720,7 +6736,7 @@
               </a:defRPr>
             </a:pPr>
             <a:r>
-              <a:t>• Bối cảnh: Dùng Android 360x800 dp, dùng 1 tay trên xe buýt / sảnh trường, hạn nộp nhóm còn đúng 5 ngày.</a:t>
+              <a:t>• Bối cảnh: Dùng Android 360x800 dp, dùng 1 tay trên xe buýt / thư viện.</a:t>
             </a:r>
           </a:p>
           <a:p>
@@ -6728,7 +6744,7 @@
               <a:spcAft>
                 <a:spcPts val="200"/>
               </a:spcAft>
-              <a:defRPr sz="1150">
+              <a:defRPr sz="1100">
                 <a:solidFill>
                   <a:srgbClr val="E2E8F0"/>
                 </a:solidFill>
@@ -6736,7 +6752,7 @@
               </a:defRPr>
             </a:pPr>
             <a:r>
-              <a:t>• Trở ngại: Không quen bạn Kinh tế, sợ ghép bừa gặp free-rider.</a:t>
+              <a:t>• Hạn chót: Nộp danh sách nhóm lên nhà trường chỉ còn đúng 5 ngày.</a:t>
             </a:r>
           </a:p>
         </p:txBody>
@@ -6749,18 +6765,18 @@
         </p:nvSpPr>
         <p:spPr>
           <a:xfrm>
-            <a:off x="731520" y="3182112"/>
-            <a:ext cx="6949440" cy="1554480"/>
+            <a:off x="548640" y="3139440"/>
+            <a:ext cx="8046720" cy="1584960"/>
           </a:xfrm>
           <a:prstGeom prst="roundRect">
             <a:avLst/>
           </a:prstGeom>
           <a:solidFill>
-            <a:srgbClr val="161E31"/>
+            <a:srgbClr val="131A2A"/>
           </a:solidFill>
           <a:ln>
             <a:solidFill>
-              <a:srgbClr val="2D3748"/>
+              <a:srgbClr val="28344B"/>
             </a:solidFill>
           </a:ln>
         </p:spPr>
@@ -6779,16 +6795,16 @@
           </a:fontRef>
         </p:style>
         <p:txBody>
-          <a:bodyPr rtlCol="0" anchor="ctr" lIns="228600" tIns="164592" rIns="228600" wrap="square"/>
+          <a:bodyPr rtlCol="0" anchor="ctr" lIns="228600" tIns="137160" rIns="228600" wrap="square"/>
           <a:lstStyle/>
           <a:p>
             <a:pPr algn="ctr">
               <a:spcAft>
-                <a:spcPts val="400"/>
-              </a:spcAft>
-              <a:defRPr sz="1300" b="1">
-                <a:solidFill>
-                  <a:srgbClr val="34D399"/>
+                <a:spcPts val="300"/>
+              </a:spcAft>
+              <a:defRPr sz="1250" b="1">
+                <a:solidFill>
+                  <a:srgbClr val="FB7185"/>
                 </a:solidFill>
                 <a:latin typeface="Arial"/>
               </a:defRPr>
@@ -6802,7 +6818,7 @@
               <a:spcAft>
                 <a:spcPts val="200"/>
               </a:spcAft>
-              <a:defRPr sz="1150">
+              <a:defRPr sz="1100">
                 <a:solidFill>
                   <a:srgbClr val="E2E8F0"/>
                 </a:solidFill>
@@ -6810,7 +6826,7 @@
               </a:defRPr>
             </a:pPr>
             <a:r>
-              <a:t>• "Sinh viên kỹ thuật phần mềm gặp khó khăn lớn khi tìm đồng đội khối ngành Kinh tế/Marketing phù hợp về kỹ năng và mức cam kết trước deadline nộp danh sách."</a:t>
+              <a:t>• "Sinh viên kỹ thuật phần mềm gặp khó khăn lớn khi tìm đồng đội khối ngành Kinh tế/Marketing phù hợp về kỹ năng và cam kết trước deadline nộp danh sách."</a:t>
             </a:r>
           </a:p>
         </p:txBody>
@@ -6823,18 +6839,18 @@
         </p:nvSpPr>
         <p:spPr>
           <a:xfrm>
-            <a:off x="731520" y="4855464"/>
-            <a:ext cx="6949440" cy="1554480"/>
+            <a:off x="548640" y="4861560"/>
+            <a:ext cx="8046720" cy="1584960"/>
           </a:xfrm>
           <a:prstGeom prst="roundRect">
             <a:avLst/>
           </a:prstGeom>
           <a:solidFill>
-            <a:srgbClr val="161E31"/>
+            <a:srgbClr val="131A2A"/>
           </a:solidFill>
           <a:ln>
             <a:solidFill>
-              <a:srgbClr val="2D3748"/>
+              <a:srgbClr val="28344B"/>
             </a:solidFill>
           </a:ln>
         </p:spPr>
@@ -6853,16 +6869,16 @@
           </a:fontRef>
         </p:style>
         <p:txBody>
-          <a:bodyPr rtlCol="0" anchor="ctr" lIns="228600" tIns="164592" rIns="228600" wrap="square"/>
+          <a:bodyPr rtlCol="0" anchor="ctr" lIns="228600" tIns="137160" rIns="228600" wrap="square"/>
           <a:lstStyle/>
           <a:p>
             <a:pPr algn="ctr">
               <a:spcAft>
-                <a:spcPts val="400"/>
-              </a:spcAft>
-              <a:defRPr sz="1300" b="1">
-                <a:solidFill>
-                  <a:srgbClr val="38BDF8"/>
+                <a:spcPts val="300"/>
+              </a:spcAft>
+              <a:defRPr sz="1250" b="1">
+                <a:solidFill>
+                  <a:srgbClr val="34D399"/>
                 </a:solidFill>
                 <a:latin typeface="Arial"/>
               </a:defRPr>
@@ -6876,9 +6892,9 @@
               <a:spcAft>
                 <a:spcPts val="200"/>
               </a:spcAft>
-              <a:defRPr sz="1150">
-                <a:solidFill>
-                  <a:srgbClr val="94A3B8"/>
+              <a:defRPr sz="1100">
+                <a:solidFill>
+                  <a:srgbClr val="E2E8F0"/>
                 </a:solidFill>
                 <a:latin typeface="Arial"/>
               </a:defRPr>
@@ -6897,18 +6913,18 @@
         </p:nvSpPr>
         <p:spPr>
           <a:xfrm>
-            <a:off x="7863840" y="1508760"/>
-            <a:ext cx="3596335" cy="4901184"/>
+            <a:off x="8778240" y="1417320"/>
+            <a:ext cx="2864815" cy="5029200"/>
           </a:xfrm>
           <a:prstGeom prst="roundRect">
             <a:avLst/>
           </a:prstGeom>
           <a:solidFill>
-            <a:srgbClr val="161E31"/>
+            <a:srgbClr val="131A2A"/>
           </a:solidFill>
           <a:ln>
             <a:solidFill>
-              <a:srgbClr val="2D3748"/>
+              <a:srgbClr val="28344B"/>
             </a:solidFill>
           </a:ln>
         </p:spPr>
@@ -6950,8 +6966,8 @@
         </p:blipFill>
         <p:spPr>
           <a:xfrm>
-            <a:off x="8092440" y="1691640"/>
-            <a:ext cx="3139135" cy="12857897"/>
+            <a:off x="9630217" y="1554480"/>
+            <a:ext cx="1160859" cy="4754880"/>
           </a:xfrm>
           <a:prstGeom prst="rect">
             <a:avLst/>
@@ -7027,18 +7043,18 @@
         </p:nvSpPr>
         <p:spPr>
           <a:xfrm>
-            <a:off x="731520" y="365760"/>
-            <a:ext cx="10728655" cy="1005840"/>
+            <a:off x="548640" y="320040"/>
+            <a:ext cx="11094415" cy="960120"/>
           </a:xfrm>
           <a:prstGeom prst="roundRect">
             <a:avLst/>
           </a:prstGeom>
           <a:solidFill>
-            <a:srgbClr val="161E31"/>
+            <a:srgbClr val="131A2A"/>
           </a:solidFill>
           <a:ln>
             <a:solidFill>
-              <a:srgbClr val="2D3748"/>
+              <a:srgbClr val="28344B"/>
             </a:solidFill>
           </a:ln>
         </p:spPr>
@@ -7069,7 +7085,7 @@
               </a:defRPr>
             </a:pPr>
             <a:r>
-              <a:t>03 / 12  ·  INFORMATION ARCHITECTURE</a:t>
+              <a:t>03  ·  INFORMATION ARCHITECTURE</a:t>
             </a:r>
           </a:p>
           <a:p>
@@ -7098,8 +7114,8 @@
         </p:nvSpPr>
         <p:spPr>
           <a:xfrm>
-            <a:off x="7772400" y="438912"/>
-            <a:ext cx="3474720" cy="457200"/>
+            <a:off x="7772400" y="384048"/>
+            <a:ext cx="3657600" cy="457200"/>
           </a:xfrm>
           <a:prstGeom prst="rect">
             <a:avLst/>
@@ -7134,18 +7150,18 @@
         </p:nvSpPr>
         <p:spPr>
           <a:xfrm>
-            <a:off x="731520" y="1508760"/>
-            <a:ext cx="6949440" cy="1554480"/>
+            <a:off x="548640" y="1417320"/>
+            <a:ext cx="4389120" cy="2432304"/>
           </a:xfrm>
           <a:prstGeom prst="roundRect">
             <a:avLst/>
           </a:prstGeom>
           <a:solidFill>
-            <a:srgbClr val="161E31"/>
+            <a:srgbClr val="131A2A"/>
           </a:solidFill>
           <a:ln>
             <a:solidFill>
-              <a:srgbClr val="2D3748"/>
+              <a:srgbClr val="28344B"/>
             </a:solidFill>
           </a:ln>
         </p:spPr>
@@ -7179,15 +7195,15 @@
               </a:defRPr>
             </a:pPr>
             <a:r>
-              <a:t>🗺️ Cấu trúc Điều hướng Phẳng</a:t>
+              <a:t>🗺️ Điều hướng Phẳng (Bottom Bar 4 Tabs)</a:t>
             </a:r>
           </a:p>
           <a:p>
             <a:pPr>
               <a:spcAft>
-                <a:spcPts val="200"/>
-              </a:spcAft>
-              <a:defRPr sz="1150">
+                <a:spcPts val="300"/>
+              </a:spcAft>
+              <a:defRPr sz="1100">
                 <a:solidFill>
                   <a:srgbClr val="E2E8F0"/>
                 </a:solidFill>
@@ -7195,15 +7211,15 @@
               </a:defRPr>
             </a:pPr>
             <a:r>
-              <a:t>• Bottom Navigation Bar 4 tab cố định: Khám phá · Đơn của tôi · Tin nhắn · Cá nhân.</a:t>
+              <a:t>• Khám phá · Đơn của tôi · Tin nhắn · Cá nhân.</a:t>
             </a:r>
           </a:p>
           <a:p>
             <a:pPr>
               <a:spcAft>
-                <a:spcPts val="200"/>
-              </a:spcAft>
-              <a:defRPr sz="1150">
+                <a:spcPts val="300"/>
+              </a:spcAft>
+              <a:defRPr sz="1100">
                 <a:solidFill>
                   <a:srgbClr val="E2E8F0"/>
                 </a:solidFill>
@@ -7211,15 +7227,15 @@
               </a:defRPr>
             </a:pPr>
             <a:r>
-              <a:t>• Thiết kế chuẩn công thái học trong vùng ngón tay cái (Thumb Zone).</a:t>
+              <a:t>• Thiết kế công thái học nằm gọn trong vùng ngón tay cái (Thumb Zone).</a:t>
             </a:r>
           </a:p>
           <a:p>
             <a:pPr>
               <a:spcAft>
-                <a:spcPts val="200"/>
-              </a:spcAft>
-              <a:defRPr sz="1150">
+                <a:spcPts val="300"/>
+              </a:spcAft>
+              <a:defRPr sz="1100">
                 <a:solidFill>
                   <a:srgbClr val="E2E8F0"/>
                 </a:solidFill>
@@ -7240,18 +7256,18 @@
         </p:nvSpPr>
         <p:spPr>
           <a:xfrm>
-            <a:off x="731520" y="3182112"/>
-            <a:ext cx="6949440" cy="1554480"/>
+            <a:off x="548640" y="4014216"/>
+            <a:ext cx="4389120" cy="2432304"/>
           </a:xfrm>
           <a:prstGeom prst="roundRect">
             <a:avLst/>
           </a:prstGeom>
           <a:solidFill>
-            <a:srgbClr val="161E31"/>
+            <a:srgbClr val="131A2A"/>
           </a:solidFill>
           <a:ln>
             <a:solidFill>
-              <a:srgbClr val="2D3748"/>
+              <a:srgbClr val="28344B"/>
             </a:solidFill>
           </a:ln>
         </p:spPr>
@@ -7291,9 +7307,9 @@
           <a:p>
             <a:pPr>
               <a:spcAft>
-                <a:spcPts val="200"/>
-              </a:spcAft>
-              <a:defRPr sz="1150">
+                <a:spcPts val="300"/>
+              </a:spcAft>
+              <a:defRPr sz="1100">
                 <a:solidFill>
                   <a:srgbClr val="E2E8F0"/>
                 </a:solidFill>
@@ -7301,15 +7317,15 @@
               </a:defRPr>
             </a:pPr>
             <a:r>
-              <a:t>• Cấp 1 (Top-Level): Screen 01 (Khám phá), Screen 05 (Theo dõi đơn), Screen 08 (Empty State).</a:t>
+              <a:t>• Cấp 1: Screen 01 (Khám phá), Screen 05 (Theo dõi đơn), Screen 08 (Empty State).</a:t>
             </a:r>
           </a:p>
           <a:p>
             <a:pPr>
               <a:spcAft>
-                <a:spcPts val="200"/>
-              </a:spcAft>
-              <a:defRPr sz="1150">
+                <a:spcPts val="300"/>
+              </a:spcAft>
+              <a:defRPr sz="1100">
                 <a:solidFill>
                   <a:srgbClr val="E2E8F0"/>
                 </a:solidFill>
@@ -7317,15 +7333,15 @@
               </a:defRPr>
             </a:pPr>
             <a:r>
-              <a:t>• Cấp 2 (Child Details): Screen 02 (Chi tiết), Screen 03 (Apply Sheet), Screen 04 (Xác nhận gửi).</a:t>
+              <a:t>• Cấp 2: Screen 02 (Chi tiết), Screen 03 (Apply Sheet), Screen 04 (Xác nhận gửi).</a:t>
             </a:r>
           </a:p>
           <a:p>
             <a:pPr>
               <a:spcAft>
-                <a:spcPts val="200"/>
-              </a:spcAft>
-              <a:defRPr sz="1150">
+                <a:spcPts val="300"/>
+              </a:spcAft>
+              <a:defRPr sz="1100">
                 <a:solidFill>
                   <a:srgbClr val="E2E8F0"/>
                 </a:solidFill>
@@ -7333,7 +7349,7 @@
               </a:defRPr>
             </a:pPr>
             <a:r>
-              <a:t>• Cấp 3 (Modals): Screen 06 (Hẹn phỏng vấn), Screen 07 (Lịch hẹn hoàn tất).</a:t>
+              <a:t>• Cấp 3: Screen 06 (Lên lịch phỏng vấn), Screen 07 (Lịch hẹn hoàn tất).</a:t>
             </a:r>
           </a:p>
         </p:txBody>
@@ -7346,18 +7362,18 @@
         </p:nvSpPr>
         <p:spPr>
           <a:xfrm>
-            <a:off x="731520" y="4855464"/>
-            <a:ext cx="6949440" cy="1554480"/>
+            <a:off x="5120640" y="1417320"/>
+            <a:ext cx="6522415" cy="5029200"/>
           </a:xfrm>
           <a:prstGeom prst="roundRect">
             <a:avLst/>
           </a:prstGeom>
           <a:solidFill>
-            <a:srgbClr val="161E31"/>
+            <a:srgbClr val="131A2A"/>
           </a:solidFill>
           <a:ln>
             <a:solidFill>
-              <a:srgbClr val="2D3748"/>
+              <a:srgbClr val="28344B"/>
             </a:solidFill>
           </a:ln>
         </p:spPr>
@@ -7376,80 +7392,6 @@
           </a:fontRef>
         </p:style>
         <p:txBody>
-          <a:bodyPr rtlCol="0" anchor="ctr" lIns="228600" tIns="164592" rIns="228600" wrap="square"/>
-          <a:lstStyle/>
-          <a:p>
-            <a:pPr algn="ctr">
-              <a:spcAft>
-                <a:spcPts val="400"/>
-              </a:spcAft>
-              <a:defRPr sz="1300" b="1">
-                <a:solidFill>
-                  <a:srgbClr val="38BDF8"/>
-                </a:solidFill>
-                <a:latin typeface="Arial"/>
-              </a:defRPr>
-            </a:pPr>
-            <a:r>
-              <a:t>📁 Minh chứng Bàn giao</a:t>
-            </a:r>
-          </a:p>
-          <a:p>
-            <a:pPr>
-              <a:spcAft>
-                <a:spcPts val="200"/>
-              </a:spcAft>
-              <a:defRPr sz="1150">
-                <a:solidFill>
-                  <a:srgbClr val="94A3B8"/>
-                </a:solidFill>
-                <a:latin typeface="Arial"/>
-              </a:defRPr>
-            </a:pPr>
-            <a:r>
-              <a:t>• Đặc tả cấu trúc chi tiết tại ux/user-flow.md và Figma Page 01 User Flow.</a:t>
-            </a:r>
-          </a:p>
-        </p:txBody>
-      </p:sp>
-      <p:sp>
-        <p:nvSpPr>
-          <p:cNvPr id="8" name="Rounded Rectangle 7"/>
-          <p:cNvSpPr/>
-          <p:nvPr/>
-        </p:nvSpPr>
-        <p:spPr>
-          <a:xfrm>
-            <a:off x="7863840" y="1508760"/>
-            <a:ext cx="3596335" cy="4901184"/>
-          </a:xfrm>
-          <a:prstGeom prst="roundRect">
-            <a:avLst/>
-          </a:prstGeom>
-          <a:solidFill>
-            <a:srgbClr val="161E31"/>
-          </a:solidFill>
-          <a:ln>
-            <a:solidFill>
-              <a:srgbClr val="2D3748"/>
-            </a:solidFill>
-          </a:ln>
-        </p:spPr>
-        <p:style>
-          <a:lnRef idx="1">
-            <a:schemeClr val="accent1"/>
-          </a:lnRef>
-          <a:fillRef idx="3">
-            <a:schemeClr val="accent1"/>
-          </a:fillRef>
-          <a:effectRef idx="2">
-            <a:schemeClr val="accent1"/>
-          </a:effectRef>
-          <a:fontRef idx="minor">
-            <a:schemeClr val="lt1"/>
-          </a:fontRef>
-        </p:style>
-        <p:txBody>
           <a:bodyPr rtlCol="0" anchor="ctr"/>
           <a:lstStyle/>
           <a:p>
@@ -7459,7 +7401,7 @@
       </p:sp>
       <p:pic>
         <p:nvPicPr>
-          <p:cNvPr id="9" name="Picture 8" descr="stitch_canvas_screen_01_02_03.png"/>
+          <p:cNvPr id="8" name="Picture 7" descr="stitch_canvas_screen_01_02_03.png"/>
           <p:cNvPicPr>
             <a:picLocks noChangeAspect="1"/>
           </p:cNvPicPr>
@@ -7473,8 +7415,8 @@
         </p:blipFill>
         <p:spPr>
           <a:xfrm>
-            <a:off x="8092440" y="1691640"/>
-            <a:ext cx="3139135" cy="1667665"/>
+            <a:off x="5318607" y="2304573"/>
+            <a:ext cx="6126480" cy="3254692"/>
           </a:xfrm>
           <a:prstGeom prst="rect">
             <a:avLst/>
@@ -7550,18 +7492,18 @@
         </p:nvSpPr>
         <p:spPr>
           <a:xfrm>
-            <a:off x="731520" y="365760"/>
-            <a:ext cx="10728655" cy="1005840"/>
+            <a:off x="548640" y="320040"/>
+            <a:ext cx="11094415" cy="960120"/>
           </a:xfrm>
           <a:prstGeom prst="roundRect">
             <a:avLst/>
           </a:prstGeom>
           <a:solidFill>
-            <a:srgbClr val="161E31"/>
+            <a:srgbClr val="131A2A"/>
           </a:solidFill>
           <a:ln>
             <a:solidFill>
-              <a:srgbClr val="2D3748"/>
+              <a:srgbClr val="28344B"/>
             </a:solidFill>
           </a:ln>
         </p:spPr>
@@ -7592,7 +7534,7 @@
               </a:defRPr>
             </a:pPr>
             <a:r>
-              <a:t>04 / 12  ·  USER FLOWS</a:t>
+              <a:t>04  ·  USER FLOWS</a:t>
             </a:r>
           </a:p>
           <a:p>
@@ -7608,7 +7550,7 @@
               </a:defRPr>
             </a:pPr>
             <a:r>
-              <a:t>3 Luồng Trải nghiệm Cốt lõi &amp; Phục hồi Lỗi</a:t>
+              <a:t>3 Luồng Trải nghiệm Cốt lõi &amp; Kịch bản Xử lý Lỗi</a:t>
             </a:r>
           </a:p>
         </p:txBody>
@@ -7621,8 +7563,8 @@
         </p:nvSpPr>
         <p:spPr>
           <a:xfrm>
-            <a:off x="7772400" y="438912"/>
-            <a:ext cx="3474720" cy="457200"/>
+            <a:off x="7772400" y="384048"/>
+            <a:ext cx="3657600" cy="457200"/>
           </a:xfrm>
           <a:prstGeom prst="rect">
             <a:avLst/>
@@ -7657,18 +7599,18 @@
         </p:nvSpPr>
         <p:spPr>
           <a:xfrm>
-            <a:off x="731520" y="1508760"/>
-            <a:ext cx="6949440" cy="1554480"/>
+            <a:off x="548640" y="1417320"/>
+            <a:ext cx="8046720" cy="1584960"/>
           </a:xfrm>
           <a:prstGeom prst="roundRect">
             <a:avLst/>
           </a:prstGeom>
           <a:solidFill>
-            <a:srgbClr val="161E31"/>
+            <a:srgbClr val="131A2A"/>
           </a:solidFill>
           <a:ln>
             <a:solidFill>
-              <a:srgbClr val="2D3748"/>
+              <a:srgbClr val="28344B"/>
             </a:solidFill>
           </a:ln>
         </p:spPr>
@@ -7687,14 +7629,14 @@
           </a:fontRef>
         </p:style>
         <p:txBody>
-          <a:bodyPr rtlCol="0" anchor="ctr" lIns="228600" tIns="164592" rIns="228600" wrap="square"/>
+          <a:bodyPr rtlCol="0" anchor="ctr" lIns="228600" tIns="137160" rIns="228600" wrap="square"/>
           <a:lstStyle/>
           <a:p>
             <a:pPr algn="ctr">
               <a:spcAft>
-                <a:spcPts val="400"/>
-              </a:spcAft>
-              <a:defRPr sz="1300" b="1">
+                <a:spcPts val="300"/>
+              </a:spcAft>
+              <a:defRPr sz="1250" b="1">
                 <a:solidFill>
                   <a:srgbClr val="38BDF8"/>
                 </a:solidFill>
@@ -7710,7 +7652,7 @@
               <a:spcAft>
                 <a:spcPts val="200"/>
               </a:spcAft>
-              <a:defRPr sz="1150">
+              <a:defRPr sz="1100">
                 <a:solidFill>
                   <a:srgbClr val="E2E8F0"/>
                 </a:solidFill>
@@ -7718,7 +7660,7 @@
               </a:defRPr>
             </a:pPr>
             <a:r>
-              <a:t>• Khám phá (Screen 01) -&gt; Xem chi tiết (Screen 02) -&gt; Nhấn Apply mở Sheet (Screen 03) -&gt; Nộp đơn thành công (Screen 04) -&gt; Quản lý tại Tracker (Screen 05).</a:t>
+              <a:t>• Khám phá (Screen 01) -&gt; Xem chi tiết (Screen 02) -&gt; Mở Apply Sheet (Screen 03) -&gt; Gửi đơn thành công (Screen 04) -&gt; Quản lý tại Tracker (Screen 05).</a:t>
             </a:r>
           </a:p>
         </p:txBody>
@@ -7731,18 +7673,18 @@
         </p:nvSpPr>
         <p:spPr>
           <a:xfrm>
-            <a:off x="731520" y="3182112"/>
-            <a:ext cx="6949440" cy="1554480"/>
+            <a:off x="548640" y="3139440"/>
+            <a:ext cx="8046720" cy="1584960"/>
           </a:xfrm>
           <a:prstGeom prst="roundRect">
             <a:avLst/>
           </a:prstGeom>
           <a:solidFill>
-            <a:srgbClr val="161E31"/>
+            <a:srgbClr val="131A2A"/>
           </a:solidFill>
           <a:ln>
             <a:solidFill>
-              <a:srgbClr val="2D3748"/>
+              <a:srgbClr val="28344B"/>
             </a:solidFill>
           </a:ln>
         </p:spPr>
@@ -7761,14 +7703,14 @@
           </a:fontRef>
         </p:style>
         <p:txBody>
-          <a:bodyPr rtlCol="0" anchor="ctr" lIns="228600" tIns="164592" rIns="228600" wrap="square"/>
+          <a:bodyPr rtlCol="0" anchor="ctr" lIns="228600" tIns="137160" rIns="228600" wrap="square"/>
           <a:lstStyle/>
           <a:p>
             <a:pPr algn="ctr">
               <a:spcAft>
-                <a:spcPts val="400"/>
-              </a:spcAft>
-              <a:defRPr sz="1300" b="1">
+                <a:spcPts val="300"/>
+              </a:spcAft>
+              <a:defRPr sz="1250" b="1">
                 <a:solidFill>
                   <a:srgbClr val="34D399"/>
                 </a:solidFill>
@@ -7784,7 +7726,7 @@
               <a:spcAft>
                 <a:spcPts val="200"/>
               </a:spcAft>
-              <a:defRPr sz="1150">
+              <a:defRPr sz="1100">
                 <a:solidFill>
                   <a:srgbClr val="E2E8F0"/>
                 </a:solidFill>
@@ -7792,7 +7734,7 @@
               </a:defRPr>
             </a:pPr>
             <a:r>
-              <a:t>• Trưởng nhóm mở Tracker (Screen 05) -&gt; Xem hồ sơ -&gt; Nhấn Hẹn trao đổi -&gt; Chọn giờ (Screen 06) -&gt; Xác nhận lịch hẹn (Screen 07).</a:t>
+              <a:t>• Trưởng nhóm mở Tracker (Screen 05) -&gt; Xem hồ sơ ứng viên -&gt; Nhấn Hẹn trao đổi -&gt; Chọn khung giờ (Screen 06) -&gt; Xác nhận lịch hẹn (Screen 07).</a:t>
             </a:r>
           </a:p>
         </p:txBody>
@@ -7805,18 +7747,18 @@
         </p:nvSpPr>
         <p:spPr>
           <a:xfrm>
-            <a:off x="731520" y="4855464"/>
-            <a:ext cx="6949440" cy="1554480"/>
+            <a:off x="548640" y="4861560"/>
+            <a:ext cx="8046720" cy="1584960"/>
           </a:xfrm>
           <a:prstGeom prst="roundRect">
             <a:avLst/>
           </a:prstGeom>
           <a:solidFill>
-            <a:srgbClr val="161E31"/>
+            <a:srgbClr val="131A2A"/>
           </a:solidFill>
           <a:ln>
             <a:solidFill>
-              <a:srgbClr val="2D3748"/>
+              <a:srgbClr val="28344B"/>
             </a:solidFill>
           </a:ln>
         </p:spPr>
@@ -7835,16 +7777,16 @@
           </a:fontRef>
         </p:style>
         <p:txBody>
-          <a:bodyPr rtlCol="0" anchor="ctr" lIns="228600" tIns="164592" rIns="228600" wrap="square"/>
+          <a:bodyPr rtlCol="0" anchor="ctr" lIns="228600" tIns="137160" rIns="228600" wrap="square"/>
           <a:lstStyle/>
           <a:p>
             <a:pPr algn="ctr">
               <a:spcAft>
-                <a:spcPts val="400"/>
-              </a:spcAft>
-              <a:defRPr sz="1300" b="1">
-                <a:solidFill>
-                  <a:srgbClr val="38BDF8"/>
+                <a:spcPts val="300"/>
+              </a:spcAft>
+              <a:defRPr sz="1250" b="1">
+                <a:solidFill>
+                  <a:srgbClr val="FB7185"/>
                 </a:solidFill>
                 <a:latin typeface="Arial"/>
               </a:defRPr>
@@ -7858,15 +7800,15 @@
               <a:spcAft>
                 <a:spcPts val="200"/>
               </a:spcAft>
-              <a:defRPr sz="1150">
-                <a:solidFill>
-                  <a:srgbClr val="94A3B8"/>
-                </a:solidFill>
-                <a:latin typeface="Arial"/>
-              </a:defRPr>
-            </a:pPr>
-            <a:r>
-              <a:t>• Tìm từ khóa sai hoặc bộ lọc quá hẹp -&gt; Screen 08 (Empty State) -&gt; Nhấn nút "Xóa bộ lọc" -&gt; Phục hồi về danh sách đầy đủ trong 1 chạm (Zero Dead-Ends).</a:t>
+              <a:defRPr sz="1100">
+                <a:solidFill>
+                  <a:srgbClr val="E2E8F0"/>
+                </a:solidFill>
+                <a:latin typeface="Arial"/>
+              </a:defRPr>
+            </a:pPr>
+            <a:r>
+              <a:t>• Tìm từ khóa sai hoặc bộ lọc quá hẹp -&gt; Màn hình Screen 08 (Empty State) -&gt; Nhấn nút 'Xóa bộ lọc' -&gt; Khôi phục danh sách đầy đủ trong 1 chạm (Zero Dead-Ends).</a:t>
             </a:r>
           </a:p>
         </p:txBody>
@@ -7879,18 +7821,18 @@
         </p:nvSpPr>
         <p:spPr>
           <a:xfrm>
-            <a:off x="7863840" y="1508760"/>
-            <a:ext cx="3596335" cy="4901184"/>
+            <a:off x="8778240" y="1417320"/>
+            <a:ext cx="2864815" cy="5029200"/>
           </a:xfrm>
           <a:prstGeom prst="roundRect">
             <a:avLst/>
           </a:prstGeom>
           <a:solidFill>
-            <a:srgbClr val="161E31"/>
+            <a:srgbClr val="131A2A"/>
           </a:solidFill>
           <a:ln>
             <a:solidFill>
-              <a:srgbClr val="2D3748"/>
+              <a:srgbClr val="28344B"/>
             </a:solidFill>
           </a:ln>
         </p:spPr>
@@ -7932,8 +7874,8 @@
         </p:blipFill>
         <p:spPr>
           <a:xfrm>
-            <a:off x="8092440" y="1691640"/>
-            <a:ext cx="3139135" cy="13282951"/>
+            <a:off x="9648791" y="1554480"/>
+            <a:ext cx="1123711" cy="4754880"/>
           </a:xfrm>
           <a:prstGeom prst="rect">
             <a:avLst/>
@@ -8009,18 +7951,18 @@
         </p:nvSpPr>
         <p:spPr>
           <a:xfrm>
-            <a:off x="731520" y="365760"/>
-            <a:ext cx="10728655" cy="1005840"/>
+            <a:off x="548640" y="320040"/>
+            <a:ext cx="11094415" cy="960120"/>
           </a:xfrm>
           <a:prstGeom prst="roundRect">
             <a:avLst/>
           </a:prstGeom>
           <a:solidFill>
-            <a:srgbClr val="161E31"/>
+            <a:srgbClr val="131A2A"/>
           </a:solidFill>
           <a:ln>
             <a:solidFill>
-              <a:srgbClr val="2D3748"/>
+              <a:srgbClr val="28344B"/>
             </a:solidFill>
           </a:ln>
         </p:spPr>
@@ -8051,7 +7993,7 @@
               </a:defRPr>
             </a:pPr>
             <a:r>
-              <a:t>05 / 12  ·  AI GENERATION</a:t>
+              <a:t>05  ·  AI GENERATION</a:t>
             </a:r>
           </a:p>
           <a:p>
@@ -8067,7 +8009,7 @@
               </a:defRPr>
             </a:pPr>
             <a:r>
-              <a:t>Ứng dụng Google Stitch: Prompt-to-UI 5 Thành phần</a:t>
+              <a:t>Ứng dụng Google Stitch · Kỹ thuật Prompt-to-UI 5 Thành phần</a:t>
             </a:r>
           </a:p>
         </p:txBody>
@@ -8080,8 +8022,8 @@
         </p:nvSpPr>
         <p:spPr>
           <a:xfrm>
-            <a:off x="7772400" y="438912"/>
-            <a:ext cx="3474720" cy="457200"/>
+            <a:off x="7772400" y="384048"/>
+            <a:ext cx="3657600" cy="457200"/>
           </a:xfrm>
           <a:prstGeom prst="rect">
             <a:avLst/>
@@ -8116,18 +8058,18 @@
         </p:nvSpPr>
         <p:spPr>
           <a:xfrm>
-            <a:off x="731520" y="1508760"/>
-            <a:ext cx="6949440" cy="1554480"/>
+            <a:off x="548640" y="1417320"/>
+            <a:ext cx="4389120" cy="2432304"/>
           </a:xfrm>
           <a:prstGeom prst="roundRect">
             <a:avLst/>
           </a:prstGeom>
           <a:solidFill>
-            <a:srgbClr val="161E31"/>
+            <a:srgbClr val="131A2A"/>
           </a:solidFill>
           <a:ln>
             <a:solidFill>
-              <a:srgbClr val="2D3748"/>
+              <a:srgbClr val="28344B"/>
             </a:solidFill>
           </a:ln>
         </p:spPr>
@@ -8167,9 +8109,9 @@
           <a:p>
             <a:pPr>
               <a:spcAft>
-                <a:spcPts val="200"/>
-              </a:spcAft>
-              <a:defRPr sz="1150">
+                <a:spcPts val="300"/>
+              </a:spcAft>
+              <a:defRPr sz="1100">
                 <a:solidFill>
                   <a:srgbClr val="E2E8F0"/>
                 </a:solidFill>
@@ -8177,15 +8119,15 @@
               </a:defRPr>
             </a:pPr>
             <a:r>
-              <a:t>• 1. Role &amp; Persona: Mobile App UX Designer thiết kế cho SV IT (Lê Quốc Huy).</a:t>
+              <a:t>• 1. Role &amp; Persona: UX Designer thiết kế cho SV IT Lê Quốc Huy.</a:t>
             </a:r>
           </a:p>
           <a:p>
             <a:pPr>
               <a:spcAft>
-                <a:spcPts val="200"/>
-              </a:spcAft>
-              <a:defRPr sz="1150">
+                <a:spcPts val="300"/>
+              </a:spcAft>
+              <a:defRPr sz="1100">
                 <a:solidFill>
                   <a:srgbClr val="E2E8F0"/>
                 </a:solidFill>
@@ -8199,9 +8141,9 @@
           <a:p>
             <a:pPr>
               <a:spcAft>
-                <a:spcPts val="200"/>
-              </a:spcAft>
-              <a:defRPr sz="1150">
+                <a:spcPts val="300"/>
+              </a:spcAft>
+              <a:defRPr sz="1100">
                 <a:solidFill>
                   <a:srgbClr val="E2E8F0"/>
                 </a:solidFill>
@@ -8209,15 +8151,15 @@
               </a:defRPr>
             </a:pPr>
             <a:r>
-              <a:t>• 3. Platform: Android Mobile 360x800 dp, Material 3 8dp grid.</a:t>
+              <a:t>• 3. Platform: Android Mobile 360x800 dp, lưới 8dp Material 3.</a:t>
             </a:r>
           </a:p>
           <a:p>
             <a:pPr>
               <a:spcAft>
-                <a:spcPts val="200"/>
-              </a:spcAft>
-              <a:defRPr sz="1150">
+                <a:spcPts val="300"/>
+              </a:spcAft>
+              <a:defRPr sz="1100">
                 <a:solidFill>
                   <a:srgbClr val="E2E8F0"/>
                 </a:solidFill>
@@ -8225,15 +8167,15 @@
               </a:defRPr>
             </a:pPr>
             <a:r>
-              <a:t>• 4. Constraints: WCAG 2.1 AA, hiển thị % tương thích và cam kết giờ.</a:t>
+              <a:t>• 4. Constraints: Chuẩn WCAG 2.1 AA, hiển thị % tương thích và cam kết giờ.</a:t>
             </a:r>
           </a:p>
           <a:p>
             <a:pPr>
               <a:spcAft>
-                <a:spcPts val="200"/>
-              </a:spcAft>
-              <a:defRPr sz="1150">
+                <a:spcPts val="300"/>
+              </a:spcAft>
+              <a:defRPr sz="1100">
                 <a:solidFill>
                   <a:srgbClr val="E2E8F0"/>
                 </a:solidFill>
@@ -8241,7 +8183,7 @@
               </a:defRPr>
             </a:pPr>
             <a:r>
-              <a:t>• 5. Style: Clean, trustworthy, Deep Navy (#0F172A) &amp; Emerald (#10B981).</a:t>
+              <a:t>• 5. Style: Bảng màu Deep Navy (#0F172A) &amp; Emerald (#10B981).</a:t>
             </a:r>
           </a:p>
         </p:txBody>
@@ -8254,18 +8196,18 @@
         </p:nvSpPr>
         <p:spPr>
           <a:xfrm>
-            <a:off x="731520" y="3182112"/>
-            <a:ext cx="6949440" cy="1554480"/>
+            <a:off x="548640" y="4014216"/>
+            <a:ext cx="4389120" cy="2432304"/>
           </a:xfrm>
           <a:prstGeom prst="roundRect">
             <a:avLst/>
           </a:prstGeom>
           <a:solidFill>
-            <a:srgbClr val="161E31"/>
+            <a:srgbClr val="131A2A"/>
           </a:solidFill>
           <a:ln>
             <a:solidFill>
-              <a:srgbClr val="2D3748"/>
+              <a:srgbClr val="28344B"/>
             </a:solidFill>
           </a:ln>
         </p:spPr>
@@ -8299,15 +8241,15 @@
               </a:defRPr>
             </a:pPr>
             <a:r>
-              <a:t>📊 Kết quả Ban đầu</a:t>
+              <a:t>📊 Kết quả Ban đầu &amp; Minh chứng</a:t>
             </a:r>
           </a:p>
           <a:p>
             <a:pPr>
               <a:spcAft>
-                <a:spcPts val="200"/>
-              </a:spcAft>
-              <a:defRPr sz="1150">
+                <a:spcPts val="300"/>
+              </a:spcAft>
+              <a:defRPr sz="1100">
                 <a:solidFill>
                   <a:srgbClr val="E2E8F0"/>
                 </a:solidFill>
@@ -8315,7 +8257,23 @@
               </a:defRPr>
             </a:pPr>
             <a:r>
-              <a:t>• Google Stitch tạo phôi 8 màn hình ban đầu thể hiện tốt cấu trúc thẻ card và layout.</a:t>
+              <a:t>• Google Stitch tạo phôi 8 màn hình ban đầu thể hiện tốt cấu trúc layout.</a:t>
+            </a:r>
+          </a:p>
+          <a:p>
+            <a:pPr>
+              <a:spcAft>
+                <a:spcPts val="300"/>
+              </a:spcAft>
+              <a:defRPr sz="1100">
+                <a:solidFill>
+                  <a:srgbClr val="E2E8F0"/>
+                </a:solidFill>
+                <a:latin typeface="Arial"/>
+              </a:defRPr>
+            </a:pPr>
+            <a:r>
+              <a:t>• Bằng chứng prompt nguyên văn lưu trữ minh bạch tại ai/ai-design-log.md.</a:t>
             </a:r>
           </a:p>
         </p:txBody>
@@ -8328,18 +8286,18 @@
         </p:nvSpPr>
         <p:spPr>
           <a:xfrm>
-            <a:off x="731520" y="4855464"/>
-            <a:ext cx="6949440" cy="1554480"/>
+            <a:off x="5120640" y="1417320"/>
+            <a:ext cx="6522415" cy="5029200"/>
           </a:xfrm>
           <a:prstGeom prst="roundRect">
             <a:avLst/>
           </a:prstGeom>
           <a:solidFill>
-            <a:srgbClr val="161E31"/>
+            <a:srgbClr val="131A2A"/>
           </a:solidFill>
           <a:ln>
             <a:solidFill>
-              <a:srgbClr val="2D3748"/>
+              <a:srgbClr val="28344B"/>
             </a:solidFill>
           </a:ln>
         </p:spPr>
@@ -8358,80 +8316,6 @@
           </a:fontRef>
         </p:style>
         <p:txBody>
-          <a:bodyPr rtlCol="0" anchor="ctr" lIns="228600" tIns="164592" rIns="228600" wrap="square"/>
-          <a:lstStyle/>
-          <a:p>
-            <a:pPr algn="ctr">
-              <a:spcAft>
-                <a:spcPts val="400"/>
-              </a:spcAft>
-              <a:defRPr sz="1300" b="1">
-                <a:solidFill>
-                  <a:srgbClr val="38BDF8"/>
-                </a:solidFill>
-                <a:latin typeface="Arial"/>
-              </a:defRPr>
-            </a:pPr>
-            <a:r>
-              <a:t>📁 Minh chứng</a:t>
-            </a:r>
-          </a:p>
-          <a:p>
-            <a:pPr>
-              <a:spcAft>
-                <a:spcPts val="200"/>
-              </a:spcAft>
-              <a:defRPr sz="1150">
-                <a:solidFill>
-                  <a:srgbClr val="94A3B8"/>
-                </a:solidFill>
-                <a:latin typeface="Arial"/>
-              </a:defRPr>
-            </a:pPr>
-            <a:r>
-              <a:t>• Toàn văn prompt và ảnh chụp trong ai/ai-design-log.md và assets/stitch/.</a:t>
-            </a:r>
-          </a:p>
-        </p:txBody>
-      </p:sp>
-      <p:sp>
-        <p:nvSpPr>
-          <p:cNvPr id="8" name="Rounded Rectangle 7"/>
-          <p:cNvSpPr/>
-          <p:nvPr/>
-        </p:nvSpPr>
-        <p:spPr>
-          <a:xfrm>
-            <a:off x="7863840" y="1508760"/>
-            <a:ext cx="3596335" cy="4901184"/>
-          </a:xfrm>
-          <a:prstGeom prst="roundRect">
-            <a:avLst/>
-          </a:prstGeom>
-          <a:solidFill>
-            <a:srgbClr val="161E31"/>
-          </a:solidFill>
-          <a:ln>
-            <a:solidFill>
-              <a:srgbClr val="2D3748"/>
-            </a:solidFill>
-          </a:ln>
-        </p:spPr>
-        <p:style>
-          <a:lnRef idx="1">
-            <a:schemeClr val="accent1"/>
-          </a:lnRef>
-          <a:fillRef idx="3">
-            <a:schemeClr val="accent1"/>
-          </a:fillRef>
-          <a:effectRef idx="2">
-            <a:schemeClr val="accent1"/>
-          </a:effectRef>
-          <a:fontRef idx="minor">
-            <a:schemeClr val="lt1"/>
-          </a:fontRef>
-        </p:style>
-        <p:txBody>
           <a:bodyPr rtlCol="0" anchor="ctr"/>
           <a:lstStyle/>
           <a:p>
@@ -8441,7 +8325,7 @@
       </p:sp>
       <p:pic>
         <p:nvPicPr>
-          <p:cNvPr id="9" name="Picture 8" descr="stitch_prompt_input_evidence.png"/>
+          <p:cNvPr id="8" name="Picture 7" descr="stitch_prompt_input_evidence.png"/>
           <p:cNvPicPr>
             <a:picLocks noChangeAspect="1"/>
           </p:cNvPicPr>
@@ -8455,8 +8339,8 @@
         </p:blipFill>
         <p:spPr>
           <a:xfrm>
-            <a:off x="8092440" y="1691640"/>
-            <a:ext cx="3139135" cy="1667665"/>
+            <a:off x="5318607" y="2304573"/>
+            <a:ext cx="6126480" cy="3254692"/>
           </a:xfrm>
           <a:prstGeom prst="rect">
             <a:avLst/>
@@ -8532,18 +8416,18 @@
         </p:nvSpPr>
         <p:spPr>
           <a:xfrm>
-            <a:off x="731520" y="365760"/>
-            <a:ext cx="10728655" cy="1005840"/>
+            <a:off x="548640" y="320040"/>
+            <a:ext cx="11094415" cy="960120"/>
           </a:xfrm>
           <a:prstGeom prst="roundRect">
             <a:avLst/>
           </a:prstGeom>
           <a:solidFill>
-            <a:srgbClr val="161E31"/>
+            <a:srgbClr val="131A2A"/>
           </a:solidFill>
           <a:ln>
             <a:solidFill>
-              <a:srgbClr val="2D3748"/>
+              <a:srgbClr val="28344B"/>
             </a:solidFill>
           </a:ln>
         </p:spPr>
@@ -8574,7 +8458,7 @@
               </a:defRPr>
             </a:pPr>
             <a:r>
-              <a:t>06 / 12  ·  UX CRITIQUE &amp; ITERATIONS</a:t>
+              <a:t>06  ·  UX CRITIQUE &amp; ITERATIONS</a:t>
             </a:r>
           </a:p>
           <a:p>
@@ -8590,7 +8474,7 @@
               </a:defRPr>
             </a:pPr>
             <a:r>
-              <a:t>3 Vòng lặp Tinh chỉnh &amp; 5 Lỗi Heuristic được Sửa</a:t>
+              <a:t>3 Vòng lặp Tinh chỉnh &amp; 5 Lỗi Heuristic được Khắc phục</a:t>
             </a:r>
           </a:p>
         </p:txBody>
@@ -8603,8 +8487,8 @@
         </p:nvSpPr>
         <p:spPr>
           <a:xfrm>
-            <a:off x="7772400" y="438912"/>
-            <a:ext cx="3474720" cy="457200"/>
+            <a:off x="7772400" y="384048"/>
+            <a:ext cx="3657600" cy="457200"/>
           </a:xfrm>
           <a:prstGeom prst="rect">
             <a:avLst/>
@@ -8639,18 +8523,18 @@
         </p:nvSpPr>
         <p:spPr>
           <a:xfrm>
-            <a:off x="731520" y="1508760"/>
-            <a:ext cx="6949440" cy="1554480"/>
+            <a:off x="548640" y="1417320"/>
+            <a:ext cx="4389120" cy="2432304"/>
           </a:xfrm>
           <a:prstGeom prst="roundRect">
             <a:avLst/>
           </a:prstGeom>
           <a:solidFill>
-            <a:srgbClr val="161E31"/>
+            <a:srgbClr val="131A2A"/>
           </a:solidFill>
           <a:ln>
             <a:solidFill>
-              <a:srgbClr val="2D3748"/>
+              <a:srgbClr val="28344B"/>
             </a:solidFill>
           </a:ln>
         </p:spPr>
@@ -8678,21 +8562,21 @@
               </a:spcAft>
               <a:defRPr sz="1300" b="1">
                 <a:solidFill>
-                  <a:srgbClr val="38BDF8"/>
-                </a:solidFill>
-                <a:latin typeface="Arial"/>
-              </a:defRPr>
-            </a:pPr>
-            <a:r>
-              <a:t>🔍 5 Lỗi Heuristic Phát hiện từ AI</a:t>
+                  <a:srgbClr val="FB7185"/>
+                </a:solidFill>
+                <a:latin typeface="Arial"/>
+              </a:defRPr>
+            </a:pPr>
+            <a:r>
+              <a:t>🔍 5 Lỗi Usability Heuristic Phát hiện từ AI</a:t>
             </a:r>
           </a:p>
           <a:p>
             <a:pPr>
               <a:spcAft>
-                <a:spcPts val="200"/>
-              </a:spcAft>
-              <a:defRPr sz="1150">
+                <a:spcPts val="300"/>
+              </a:spcAft>
+              <a:defRPr sz="1100">
                 <a:solidFill>
                   <a:srgbClr val="E2E8F0"/>
                 </a:solidFill>
@@ -8700,15 +8584,15 @@
               </a:defRPr>
             </a:pPr>
             <a:r>
-              <a:t>• H1 (Visibility): Nút Apply ban đầu thiếu loading feedback khi nhấn.</a:t>
+              <a:t>• H1 (Visibility): Nút Apply ban đầu không có loading feedback khi nhấn.</a:t>
             </a:r>
           </a:p>
           <a:p>
             <a:pPr>
               <a:spcAft>
-                <a:spcPts val="200"/>
-              </a:spcAft>
-              <a:defRPr sz="1150">
+                <a:spcPts val="300"/>
+              </a:spcAft>
+              <a:defRPr sz="1100">
                 <a:solidFill>
                   <a:srgbClr val="E2E8F0"/>
                 </a:solidFill>
@@ -8722,9 +8606,9 @@
           <a:p>
             <a:pPr>
               <a:spcAft>
-                <a:spcPts val="200"/>
-              </a:spcAft>
-              <a:defRPr sz="1150">
+                <a:spcPts val="300"/>
+              </a:spcAft>
+              <a:defRPr sz="1100">
                 <a:solidFill>
                   <a:srgbClr val="E2E8F0"/>
                 </a:solidFill>
@@ -8738,9 +8622,9 @@
           <a:p>
             <a:pPr>
               <a:spcAft>
-                <a:spcPts val="200"/>
-              </a:spcAft>
-              <a:defRPr sz="1150">
+                <a:spcPts val="300"/>
+              </a:spcAft>
+              <a:defRPr sz="1100">
                 <a:solidFill>
                   <a:srgbClr val="E2E8F0"/>
                 </a:solidFill>
@@ -8754,9 +8638,9 @@
           <a:p>
             <a:pPr>
               <a:spcAft>
-                <a:spcPts val="200"/>
-              </a:spcAft>
-              <a:defRPr sz="1150">
+                <a:spcPts val="300"/>
+              </a:spcAft>
+              <a:defRPr sz="1100">
                 <a:solidFill>
                   <a:srgbClr val="E2E8F0"/>
                 </a:solidFill>
@@ -8777,18 +8661,18 @@
         </p:nvSpPr>
         <p:spPr>
           <a:xfrm>
-            <a:off x="731520" y="3182112"/>
-            <a:ext cx="6949440" cy="1554480"/>
+            <a:off x="548640" y="4014216"/>
+            <a:ext cx="4389120" cy="2432304"/>
           </a:xfrm>
           <a:prstGeom prst="roundRect">
             <a:avLst/>
           </a:prstGeom>
           <a:solidFill>
-            <a:srgbClr val="161E31"/>
+            <a:srgbClr val="131A2A"/>
           </a:solidFill>
           <a:ln>
             <a:solidFill>
-              <a:srgbClr val="2D3748"/>
+              <a:srgbClr val="28344B"/>
             </a:solidFill>
           </a:ln>
         </p:spPr>
@@ -8828,9 +8712,9 @@
           <a:p>
             <a:pPr>
               <a:spcAft>
-                <a:spcPts val="200"/>
-              </a:spcAft>
-              <a:defRPr sz="1150">
+                <a:spcPts val="300"/>
+              </a:spcAft>
+              <a:defRPr sz="1100">
                 <a:solidFill>
                   <a:srgbClr val="E2E8F0"/>
                 </a:solidFill>
@@ -8844,9 +8728,9 @@
           <a:p>
             <a:pPr>
               <a:spcAft>
-                <a:spcPts val="200"/>
-              </a:spcAft>
-              <a:defRPr sz="1150">
+                <a:spcPts val="300"/>
+              </a:spcAft>
+              <a:defRPr sz="1100">
                 <a:solidFill>
                   <a:srgbClr val="E2E8F0"/>
                 </a:solidFill>
@@ -8860,9 +8744,9 @@
           <a:p>
             <a:pPr>
               <a:spcAft>
-                <a:spcPts val="200"/>
-              </a:spcAft>
-              <a:defRPr sz="1150">
+                <a:spcPts val="300"/>
+              </a:spcAft>
+              <a:defRPr sz="1100">
                 <a:solidFill>
                   <a:srgbClr val="E2E8F0"/>
                 </a:solidFill>
@@ -8883,18 +8767,18 @@
         </p:nvSpPr>
         <p:spPr>
           <a:xfrm>
-            <a:off x="731520" y="4855464"/>
-            <a:ext cx="6949440" cy="1554480"/>
+            <a:off x="5120640" y="1417320"/>
+            <a:ext cx="6522415" cy="5029200"/>
           </a:xfrm>
           <a:prstGeom prst="roundRect">
             <a:avLst/>
           </a:prstGeom>
           <a:solidFill>
-            <a:srgbClr val="161E31"/>
+            <a:srgbClr val="131A2A"/>
           </a:solidFill>
           <a:ln>
             <a:solidFill>
-              <a:srgbClr val="2D3748"/>
+              <a:srgbClr val="28344B"/>
             </a:solidFill>
           </a:ln>
         </p:spPr>
@@ -8913,80 +8797,6 @@
           </a:fontRef>
         </p:style>
         <p:txBody>
-          <a:bodyPr rtlCol="0" anchor="ctr" lIns="228600" tIns="164592" rIns="228600" wrap="square"/>
-          <a:lstStyle/>
-          <a:p>
-            <a:pPr algn="ctr">
-              <a:spcAft>
-                <a:spcPts val="400"/>
-              </a:spcAft>
-              <a:defRPr sz="1300" b="1">
-                <a:solidFill>
-                  <a:srgbClr val="38BDF8"/>
-                </a:solidFill>
-                <a:latin typeface="Arial"/>
-              </a:defRPr>
-            </a:pPr>
-            <a:r>
-              <a:t>📁 Minh chứng</a:t>
-            </a:r>
-          </a:p>
-          <a:p>
-            <a:pPr>
-              <a:spcAft>
-                <a:spcPts val="200"/>
-              </a:spcAft>
-              <a:defRPr sz="1150">
-                <a:solidFill>
-                  <a:srgbClr val="94A3B8"/>
-                </a:solidFill>
-                <a:latin typeface="Arial"/>
-              </a:defRPr>
-            </a:pPr>
-            <a:r>
-              <a:t>• Bảng đối chiếu Before/After chi tiết tại ai/ai-design-log.md.</a:t>
-            </a:r>
-          </a:p>
-        </p:txBody>
-      </p:sp>
-      <p:sp>
-        <p:nvSpPr>
-          <p:cNvPr id="8" name="Rounded Rectangle 7"/>
-          <p:cNvSpPr/>
-          <p:nvPr/>
-        </p:nvSpPr>
-        <p:spPr>
-          <a:xfrm>
-            <a:off x="7863840" y="1508760"/>
-            <a:ext cx="3596335" cy="4901184"/>
-          </a:xfrm>
-          <a:prstGeom prst="roundRect">
-            <a:avLst/>
-          </a:prstGeom>
-          <a:solidFill>
-            <a:srgbClr val="161E31"/>
-          </a:solidFill>
-          <a:ln>
-            <a:solidFill>
-              <a:srgbClr val="2D3748"/>
-            </a:solidFill>
-          </a:ln>
-        </p:spPr>
-        <p:style>
-          <a:lnRef idx="1">
-            <a:schemeClr val="accent1"/>
-          </a:lnRef>
-          <a:fillRef idx="3">
-            <a:schemeClr val="accent1"/>
-          </a:fillRef>
-          <a:effectRef idx="2">
-            <a:schemeClr val="accent1"/>
-          </a:effectRef>
-          <a:fontRef idx="minor">
-            <a:schemeClr val="lt1"/>
-          </a:fontRef>
-        </p:style>
-        <p:txBody>
           <a:bodyPr rtlCol="0" anchor="ctr"/>
           <a:lstStyle/>
           <a:p>
@@ -8996,7 +8806,7 @@
       </p:sp>
       <p:pic>
         <p:nvPicPr>
-          <p:cNvPr id="9" name="Picture 8" descr="figma_canvas_7_screens.png"/>
+          <p:cNvPr id="8" name="Picture 7" descr="figma_canvas_7_screens.png"/>
           <p:cNvPicPr>
             <a:picLocks noChangeAspect="1"/>
           </p:cNvPicPr>
@@ -9010,8 +8820,8 @@
         </p:blipFill>
         <p:spPr>
           <a:xfrm>
-            <a:off x="8092440" y="1691640"/>
-            <a:ext cx="3139135" cy="1667665"/>
+            <a:off x="5318607" y="2304573"/>
+            <a:ext cx="6126480" cy="3254692"/>
           </a:xfrm>
           <a:prstGeom prst="rect">
             <a:avLst/>
@@ -9087,18 +8897,18 @@
         </p:nvSpPr>
         <p:spPr>
           <a:xfrm>
-            <a:off x="731520" y="365760"/>
-            <a:ext cx="10728655" cy="1005840"/>
+            <a:off x="548640" y="320040"/>
+            <a:ext cx="11094415" cy="960120"/>
           </a:xfrm>
           <a:prstGeom prst="roundRect">
             <a:avLst/>
           </a:prstGeom>
           <a:solidFill>
-            <a:srgbClr val="161E31"/>
+            <a:srgbClr val="131A2A"/>
           </a:solidFill>
           <a:ln>
             <a:solidFill>
-              <a:srgbClr val="2D3748"/>
+              <a:srgbClr val="28344B"/>
             </a:solidFill>
           </a:ln>
         </p:spPr>
@@ -9129,7 +8939,7 @@
               </a:defRPr>
             </a:pPr>
             <a:r>
-              <a:t>07 / 12  ·  DESIGN DECISIONS</a:t>
+              <a:t>07  ·  DESIGN DECISIONS</a:t>
             </a:r>
           </a:p>
           <a:p>
@@ -9158,8 +8968,8 @@
         </p:nvSpPr>
         <p:spPr>
           <a:xfrm>
-            <a:off x="7772400" y="438912"/>
-            <a:ext cx="3474720" cy="457200"/>
+            <a:off x="7772400" y="384048"/>
+            <a:ext cx="3657600" cy="457200"/>
           </a:xfrm>
           <a:prstGeom prst="rect">
             <a:avLst/>
@@ -9194,18 +9004,18 @@
         </p:nvSpPr>
         <p:spPr>
           <a:xfrm>
-            <a:off x="731520" y="1508760"/>
-            <a:ext cx="6949440" cy="1554480"/>
+            <a:off x="548640" y="1417320"/>
+            <a:ext cx="8046720" cy="1584960"/>
           </a:xfrm>
           <a:prstGeom prst="roundRect">
             <a:avLst/>
           </a:prstGeom>
           <a:solidFill>
-            <a:srgbClr val="161E31"/>
+            <a:srgbClr val="131A2A"/>
           </a:solidFill>
           <a:ln>
             <a:solidFill>
-              <a:srgbClr val="2D3748"/>
+              <a:srgbClr val="28344B"/>
             </a:solidFill>
           </a:ln>
         </p:spPr>
@@ -9224,16 +9034,16 @@
           </a:fontRef>
         </p:style>
         <p:txBody>
-          <a:bodyPr rtlCol="0" anchor="ctr" lIns="228600" tIns="164592" rIns="228600" wrap="square"/>
+          <a:bodyPr rtlCol="0" anchor="ctr" lIns="228600" tIns="137160" rIns="228600" wrap="square"/>
           <a:lstStyle/>
           <a:p>
             <a:pPr algn="ctr">
               <a:spcAft>
-                <a:spcPts val="400"/>
-              </a:spcAft>
-              <a:defRPr sz="1300" b="1">
-                <a:solidFill>
-                  <a:srgbClr val="38BDF8"/>
+                <a:spcPts val="300"/>
+              </a:spcAft>
+              <a:defRPr sz="1250" b="1">
+                <a:solidFill>
+                  <a:srgbClr val="34D399"/>
                 </a:solidFill>
                 <a:latin typeface="Arial"/>
               </a:defRPr>
@@ -9247,7 +9057,7 @@
               <a:spcAft>
                 <a:spcPts val="200"/>
               </a:spcAft>
-              <a:defRPr sz="1150">
+              <a:defRPr sz="1100">
                 <a:solidFill>
                   <a:srgbClr val="E2E8F0"/>
                 </a:solidFill>
@@ -9263,7 +9073,7 @@
               <a:spcAft>
                 <a:spcPts val="200"/>
               </a:spcAft>
-              <a:defRPr sz="1150">
+              <a:defRPr sz="1100">
                 <a:solidFill>
                   <a:srgbClr val="E2E8F0"/>
                 </a:solidFill>
@@ -9271,7 +9081,7 @@
               </a:defRPr>
             </a:pPr>
             <a:r>
-              <a:t>• MODIFY - Nút Apply trôi nổi: Nút bấm ban đầu lơ lửng giữa thẻ -&gt; Chuyển thành Sticky Bottom Dock (48x56 dp) cố định đáy dễ bấm 1 tay.</a:t>
+              <a:t>• MODIFY - Nút Apply trôi nổi: Nút ban đầu lơ lửng giữa thẻ -&gt; Chuyển thành Sticky Bottom Dock (48x56 dp) cố định đáy dễ bấm 1 tay.</a:t>
             </a:r>
           </a:p>
         </p:txBody>
@@ -9284,18 +9094,18 @@
         </p:nvSpPr>
         <p:spPr>
           <a:xfrm>
-            <a:off x="731520" y="3182112"/>
-            <a:ext cx="6949440" cy="1554480"/>
+            <a:off x="548640" y="3139440"/>
+            <a:ext cx="8046720" cy="1584960"/>
           </a:xfrm>
           <a:prstGeom prst="roundRect">
             <a:avLst/>
           </a:prstGeom>
           <a:solidFill>
-            <a:srgbClr val="161E31"/>
+            <a:srgbClr val="131A2A"/>
           </a:solidFill>
           <a:ln>
             <a:solidFill>
-              <a:srgbClr val="2D3748"/>
+              <a:srgbClr val="28344B"/>
             </a:solidFill>
           </a:ln>
         </p:spPr>
@@ -9314,16 +9124,16 @@
           </a:fontRef>
         </p:style>
         <p:txBody>
-          <a:bodyPr rtlCol="0" anchor="ctr" lIns="228600" tIns="164592" rIns="228600" wrap="square"/>
+          <a:bodyPr rtlCol="0" anchor="ctr" lIns="228600" tIns="137160" rIns="228600" wrap="square"/>
           <a:lstStyle/>
           <a:p>
             <a:pPr algn="ctr">
               <a:spcAft>
-                <a:spcPts val="400"/>
-              </a:spcAft>
-              <a:defRPr sz="1300" b="1">
-                <a:solidFill>
-                  <a:srgbClr val="34D399"/>
+                <a:spcPts val="300"/>
+              </a:spcAft>
+              <a:defRPr sz="1250" b="1">
+                <a:solidFill>
+                  <a:srgbClr val="FB7185"/>
                 </a:solidFill>
                 <a:latin typeface="Arial"/>
               </a:defRPr>
@@ -9337,7 +9147,7 @@
               <a:spcAft>
                 <a:spcPts val="200"/>
               </a:spcAft>
-              <a:defRPr sz="1150">
+              <a:defRPr sz="1100">
                 <a:solidFill>
                   <a:srgbClr val="E2E8F0"/>
                 </a:solidFill>
@@ -9353,7 +9163,7 @@
               <a:spcAft>
                 <a:spcPts val="200"/>
               </a:spcAft>
-              <a:defRPr sz="1150">
+              <a:defRPr sz="1100">
                 <a:solidFill>
                   <a:srgbClr val="E2E8F0"/>
                 </a:solidFill>
@@ -9374,18 +9184,18 @@
         </p:nvSpPr>
         <p:spPr>
           <a:xfrm>
-            <a:off x="731520" y="4855464"/>
-            <a:ext cx="6949440" cy="1554480"/>
+            <a:off x="548640" y="4861560"/>
+            <a:ext cx="8046720" cy="1584960"/>
           </a:xfrm>
           <a:prstGeom prst="roundRect">
             <a:avLst/>
           </a:prstGeom>
           <a:solidFill>
-            <a:srgbClr val="161E31"/>
+            <a:srgbClr val="131A2A"/>
           </a:solidFill>
           <a:ln>
             <a:solidFill>
-              <a:srgbClr val="2D3748"/>
+              <a:srgbClr val="28344B"/>
             </a:solidFill>
           </a:ln>
         </p:spPr>
@@ -9404,14 +9214,14 @@
           </a:fontRef>
         </p:style>
         <p:txBody>
-          <a:bodyPr rtlCol="0" anchor="ctr" lIns="228600" tIns="164592" rIns="228600" wrap="square"/>
+          <a:bodyPr rtlCol="0" anchor="ctr" lIns="228600" tIns="137160" rIns="228600" wrap="square"/>
           <a:lstStyle/>
           <a:p>
             <a:pPr algn="ctr">
               <a:spcAft>
-                <a:spcPts val="400"/>
-              </a:spcAft>
-              <a:defRPr sz="1300" b="1">
+                <a:spcPts val="300"/>
+              </a:spcAft>
+              <a:defRPr sz="1250" b="1">
                 <a:solidFill>
                   <a:srgbClr val="38BDF8"/>
                 </a:solidFill>
@@ -9427,15 +9237,15 @@
               <a:spcAft>
                 <a:spcPts val="200"/>
               </a:spcAft>
-              <a:defRPr sz="1150">
-                <a:solidFill>
-                  <a:srgbClr val="94A3B8"/>
-                </a:solidFill>
-                <a:latin typeface="Arial"/>
-              </a:defRPr>
-            </a:pPr>
-            <a:r>
-              <a:t>• Hồ sơ 10 quyết định thiết kế tại design/design-decisions.md.</a:t>
+              <a:defRPr sz="1100">
+                <a:solidFill>
+                  <a:srgbClr val="E2E8F0"/>
+                </a:solidFill>
+                <a:latin typeface="Arial"/>
+              </a:defRPr>
+            </a:pPr>
+            <a:r>
+              <a:t>• Xem chi tiết 10 quyết định thiết kế tại file design/design-decisions.md.</a:t>
             </a:r>
           </a:p>
         </p:txBody>
@@ -9448,18 +9258,18 @@
         </p:nvSpPr>
         <p:spPr>
           <a:xfrm>
-            <a:off x="7863840" y="1508760"/>
-            <a:ext cx="3596335" cy="4901184"/>
+            <a:off x="8778240" y="1417320"/>
+            <a:ext cx="2864815" cy="5029200"/>
           </a:xfrm>
           <a:prstGeom prst="roundRect">
             <a:avLst/>
           </a:prstGeom>
           <a:solidFill>
-            <a:srgbClr val="161E31"/>
+            <a:srgbClr val="131A2A"/>
           </a:solidFill>
           <a:ln>
             <a:solidFill>
-              <a:srgbClr val="2D3748"/>
+              <a:srgbClr val="28344B"/>
             </a:solidFill>
           </a:ln>
         </p:spPr>
@@ -9501,8 +9311,8 @@
         </p:blipFill>
         <p:spPr>
           <a:xfrm>
-            <a:off x="8092440" y="1691640"/>
-            <a:ext cx="3139135" cy="11861529"/>
+            <a:off x="9581461" y="1554480"/>
+            <a:ext cx="1258371" cy="4754880"/>
           </a:xfrm>
           <a:prstGeom prst="rect">
             <a:avLst/>
@@ -9578,18 +9388,18 @@
         </p:nvSpPr>
         <p:spPr>
           <a:xfrm>
-            <a:off x="731520" y="365760"/>
-            <a:ext cx="10728655" cy="1005840"/>
+            <a:off x="548640" y="320040"/>
+            <a:ext cx="11094415" cy="960120"/>
           </a:xfrm>
           <a:prstGeom prst="roundRect">
             <a:avLst/>
           </a:prstGeom>
           <a:solidFill>
-            <a:srgbClr val="161E31"/>
+            <a:srgbClr val="131A2A"/>
           </a:solidFill>
           <a:ln>
             <a:solidFill>
-              <a:srgbClr val="2D3748"/>
+              <a:srgbClr val="28344B"/>
             </a:solidFill>
           </a:ln>
         </p:spPr>
@@ -9620,7 +9430,7 @@
               </a:defRPr>
             </a:pPr>
             <a:r>
-              <a:t>08 / 12  ·  FINAL UI SCREENS</a:t>
+              <a:t>08  ·  FINAL UI SHOWCASE</a:t>
             </a:r>
           </a:p>
           <a:p>
@@ -9636,7 +9446,7 @@
               </a:defRPr>
             </a:pPr>
             <a:r>
-              <a:t>Chuyển hóa: Wireframe sang 8 Màn hình Hoàn chỉnh</a:t>
+              <a:t>8 Màn hình Chức năng Hoàn chỉnh (Chuẩn C6 Môn học)</a:t>
             </a:r>
           </a:p>
         </p:txBody>
@@ -9649,8 +9459,8 @@
         </p:nvSpPr>
         <p:spPr>
           <a:xfrm>
-            <a:off x="7772400" y="438912"/>
-            <a:ext cx="3474720" cy="457200"/>
+            <a:off x="7772400" y="384048"/>
+            <a:ext cx="3657600" cy="457200"/>
           </a:xfrm>
           <a:prstGeom prst="rect">
             <a:avLst/>
@@ -9685,18 +9495,18 @@
         </p:nvSpPr>
         <p:spPr>
           <a:xfrm>
-            <a:off x="731520" y="1508760"/>
-            <a:ext cx="6949440" cy="1554480"/>
+            <a:off x="548640" y="1417320"/>
+            <a:ext cx="4389120" cy="2432304"/>
           </a:xfrm>
           <a:prstGeom prst="roundRect">
             <a:avLst/>
           </a:prstGeom>
           <a:solidFill>
-            <a:srgbClr val="161E31"/>
+            <a:srgbClr val="131A2A"/>
           </a:solidFill>
           <a:ln>
             <a:solidFill>
-              <a:srgbClr val="2D3748"/>
+              <a:srgbClr val="28344B"/>
             </a:solidFill>
           </a:ln>
         </p:spPr>
@@ -9730,15 +9540,15 @@
               </a:defRPr>
             </a:pPr>
             <a:r>
-              <a:t>📱 8 Màn hình Chức năng Độc lập (Chuẩn C6)</a:t>
+              <a:t>📱 Danh mục 8 Màn hình Độc lập</a:t>
             </a:r>
           </a:p>
           <a:p>
             <a:pPr>
               <a:spcAft>
-                <a:spcPts val="200"/>
-              </a:spcAft>
-              <a:defRPr sz="1150">
+                <a:spcPts val="300"/>
+              </a:spcAft>
+              <a:defRPr sz="1100">
                 <a:solidFill>
                   <a:srgbClr val="E2E8F0"/>
                 </a:solidFill>
@@ -9746,15 +9556,15 @@
               </a:defRPr>
             </a:pPr>
             <a:r>
-              <a:t>• Screen 01: Discovery Feed (Khám phá dự án &amp; bộ lọc)</a:t>
+              <a:t>• Screen 01: Discovery Feed (Khám phá dự án &amp; bộ lọc chuyên môn)</a:t>
             </a:r>
           </a:p>
           <a:p>
             <a:pPr>
               <a:spcAft>
-                <a:spcPts val="200"/>
-              </a:spcAft>
-              <a:defRPr sz="1150">
+                <a:spcPts val="300"/>
+              </a:spcAft>
+              <a:defRPr sz="1100">
                 <a:solidFill>
                   <a:srgbClr val="E2E8F0"/>
                 </a:solidFill>
@@ -9762,15 +9572,15 @@
               </a:defRPr>
             </a:pPr>
             <a:r>
-              <a:t>• Screen 02: Project Detail (Chi tiết dự án &amp; Skill Matrix)</a:t>
+              <a:t>• Screen 02: Project Detail (Chi tiết dự án &amp; Skill Matrix nhóm)</a:t>
             </a:r>
           </a:p>
           <a:p>
             <a:pPr>
               <a:spcAft>
-                <a:spcPts val="200"/>
-              </a:spcAft>
-              <a:defRPr sz="1150">
+                <a:spcPts val="300"/>
+              </a:spcAft>
+              <a:defRPr sz="1100">
                 <a:solidFill>
                   <a:srgbClr val="E2E8F0"/>
                 </a:solidFill>
@@ -9778,15 +9588,15 @@
               </a:defRPr>
             </a:pPr>
             <a:r>
-              <a:t>• Screen 03: Apply Modal Sheet (Nộp đơn ứng tuyển)</a:t>
+              <a:t>• Screen 03: Apply Modal Sheet (Nộp đơn ứng tuyển &amp; cam kết giờ)</a:t>
             </a:r>
           </a:p>
           <a:p>
             <a:pPr>
               <a:spcAft>
-                <a:spcPts val="200"/>
-              </a:spcAft>
-              <a:defRPr sz="1150">
+                <a:spcPts val="300"/>
+              </a:spcAft>
+              <a:defRPr sz="1100">
                 <a:solidFill>
                   <a:srgbClr val="E2E8F0"/>
                 </a:solidFill>
@@ -9794,15 +9604,15 @@
               </a:defRPr>
             </a:pPr>
             <a:r>
-              <a:t>• Screen 04: Application Submitted (Xác nhận gửi đơn)</a:t>
+              <a:t>• Screen 04: Application Submitted (Xác nhận gửi đơn thành công)</a:t>
             </a:r>
           </a:p>
           <a:p>
             <a:pPr>
               <a:spcAft>
-                <a:spcPts val="200"/>
-              </a:spcAft>
-              <a:defRPr sz="1150">
+                <a:spcPts val="300"/>
+              </a:spcAft>
+              <a:defRPr sz="1100">
                 <a:solidFill>
                   <a:srgbClr val="E2E8F0"/>
                 </a:solidFill>
@@ -9810,15 +9620,15 @@
               </a:defRPr>
             </a:pPr>
             <a:r>
-              <a:t>• Screen 05: Applications Tracker (Theo dõi tiến độ)</a:t>
+              <a:t>• Screen 05: Applications Tracker (Theo dõi tiến độ đơn thời gian thực)</a:t>
             </a:r>
           </a:p>
           <a:p>
             <a:pPr>
               <a:spcAft>
-                <a:spcPts val="200"/>
-              </a:spcAft>
-              <a:defRPr sz="1150">
+                <a:spcPts val="300"/>
+              </a:spcAft>
+              <a:defRPr sz="1100">
                 <a:solidFill>
                   <a:srgbClr val="E2E8F0"/>
                 </a:solidFill>
@@ -9826,15 +9636,15 @@
               </a:defRPr>
             </a:pPr>
             <a:r>
-              <a:t>• Screen 06: Chemistry Call Scheduler (Lên lịch trao đổi)</a:t>
+              <a:t>• Screen 06: Chemistry Call Scheduler (Lên lịch phỏng vấn kết nối)</a:t>
             </a:r>
           </a:p>
           <a:p>
             <a:pPr>
               <a:spcAft>
-                <a:spcPts val="200"/>
-              </a:spcAft>
-              <a:defRPr sz="1150">
+                <a:spcPts val="300"/>
+              </a:spcAft>
+              <a:defRPr sz="1100">
                 <a:solidFill>
                   <a:srgbClr val="E2E8F0"/>
                 </a:solidFill>
@@ -9842,15 +9652,15 @@
               </a:defRPr>
             </a:pPr>
             <a:r>
-              <a:t>• Screen 07: Chemistry Call Confirmed (Lịch hẹn hoàn tất)</a:t>
+              <a:t>• Screen 07: Chemistry Call Confirmed (Lịch hẹn kết nối hoàn tất)</a:t>
             </a:r>
           </a:p>
           <a:p>
             <a:pPr>
               <a:spcAft>
-                <a:spcPts val="200"/>
-              </a:spcAft>
-              <a:defRPr sz="1150">
+                <a:spcPts val="300"/>
+              </a:spcAft>
+              <a:defRPr sz="1100">
                 <a:solidFill>
                   <a:srgbClr val="E2E8F0"/>
                 </a:solidFill>
@@ -9858,7 +9668,7 @@
               </a:defRPr>
             </a:pPr>
             <a:r>
-              <a:t>• Screen 08: Empty State Recovery (Phục hồi tìm kiếm)</a:t>
+              <a:t>• Screen 08: Empty State Recovery (Phục hồi tìm kiếm không ngõ cụt)</a:t>
             </a:r>
           </a:p>
         </p:txBody>
@@ -9871,18 +9681,18 @@
         </p:nvSpPr>
         <p:spPr>
           <a:xfrm>
-            <a:off x="731520" y="3182112"/>
-            <a:ext cx="6949440" cy="1554480"/>
+            <a:off x="548640" y="4014216"/>
+            <a:ext cx="4389120" cy="2432304"/>
           </a:xfrm>
           <a:prstGeom prst="roundRect">
             <a:avLst/>
           </a:prstGeom>
           <a:solidFill>
-            <a:srgbClr val="161E31"/>
+            <a:srgbClr val="131A2A"/>
           </a:solidFill>
           <a:ln>
             <a:solidFill>
-              <a:srgbClr val="2D3748"/>
+              <a:srgbClr val="28344B"/>
             </a:solidFill>
           </a:ln>
         </p:spPr>
@@ -9916,15 +9726,15 @@
               </a:defRPr>
             </a:pPr>
             <a:r>
-              <a:t>🎨 Tính Nhất quán Thị giác</a:t>
+              <a:t>🎨 Tiêu chuẩn Kiểm định</a:t>
             </a:r>
           </a:p>
           <a:p>
             <a:pPr>
               <a:spcAft>
-                <a:spcPts val="200"/>
-              </a:spcAft>
-              <a:defRPr sz="1150">
+                <a:spcPts val="300"/>
+              </a:spcAft>
+              <a:defRPr sz="1100">
                 <a:solidFill>
                   <a:srgbClr val="E2E8F0"/>
                 </a:solidFill>
@@ -9932,15 +9742,15 @@
               </a:defRPr>
             </a:pPr>
             <a:r>
-              <a:t>• Tuân thủ hệ thống lưới cơ sở 8dp và phân cấp typography rõ ràng.</a:t>
+              <a:t>• Tuân thủ nghiêm ngặt hệ thống lưới cơ sở 8dp và chuẩn tương phản WCAG 2.1 AA.</a:t>
             </a:r>
           </a:p>
           <a:p>
             <a:pPr>
               <a:spcAft>
-                <a:spcPts val="200"/>
-              </a:spcAft>
-              <a:defRPr sz="1150">
+                <a:spcPts val="300"/>
+              </a:spcAft>
+              <a:defRPr sz="1100">
                 <a:solidFill>
                   <a:srgbClr val="E2E8F0"/>
                 </a:solidFill>
@@ -9948,7 +9758,7 @@
               </a:defRPr>
             </a:pPr>
             <a:r>
-              <a:t>• Không tính các biến thể pop-up nhỏ, đảm bảo đủ 8 màn hình riêng biệt.</a:t>
+              <a:t>• Không tính các dialog nhỏ hay trạng thái biến thể, đủ 8 màn hình riêng biệt.</a:t>
             </a:r>
           </a:p>
         </p:txBody>
@@ -9961,18 +9771,18 @@
         </p:nvSpPr>
         <p:spPr>
           <a:xfrm>
-            <a:off x="731520" y="4855464"/>
-            <a:ext cx="6949440" cy="1554480"/>
+            <a:off x="5120640" y="1417320"/>
+            <a:ext cx="6522415" cy="5029200"/>
           </a:xfrm>
           <a:prstGeom prst="roundRect">
             <a:avLst/>
           </a:prstGeom>
           <a:solidFill>
-            <a:srgbClr val="161E31"/>
+            <a:srgbClr val="131A2A"/>
           </a:solidFill>
           <a:ln>
             <a:solidFill>
-              <a:srgbClr val="2D3748"/>
+              <a:srgbClr val="28344B"/>
             </a:solidFill>
           </a:ln>
         </p:spPr>
@@ -9991,80 +9801,6 @@
           </a:fontRef>
         </p:style>
         <p:txBody>
-          <a:bodyPr rtlCol="0" anchor="ctr" lIns="228600" tIns="164592" rIns="228600" wrap="square"/>
-          <a:lstStyle/>
-          <a:p>
-            <a:pPr algn="ctr">
-              <a:spcAft>
-                <a:spcPts val="400"/>
-              </a:spcAft>
-              <a:defRPr sz="1300" b="1">
-                <a:solidFill>
-                  <a:srgbClr val="38BDF8"/>
-                </a:solidFill>
-                <a:latin typeface="Arial"/>
-              </a:defRPr>
-            </a:pPr>
-            <a:r>
-              <a:t>📁 Minh chứng</a:t>
-            </a:r>
-          </a:p>
-          <a:p>
-            <a:pPr>
-              <a:spcAft>
-                <a:spcPts val="200"/>
-              </a:spcAft>
-              <a:defRPr sz="1150">
-                <a:solidFill>
-                  <a:srgbClr val="94A3B8"/>
-                </a:solidFill>
-                <a:latin typeface="Arial"/>
-              </a:defRPr>
-            </a:pPr>
-            <a:r>
-              <a:t>• Kiểm tra tại Figma Page 02 Wireframe và Page 03 Final UI.</a:t>
-            </a:r>
-          </a:p>
-        </p:txBody>
-      </p:sp>
-      <p:sp>
-        <p:nvSpPr>
-          <p:cNvPr id="8" name="Rounded Rectangle 7"/>
-          <p:cNvSpPr/>
-          <p:nvPr/>
-        </p:nvSpPr>
-        <p:spPr>
-          <a:xfrm>
-            <a:off x="7863840" y="1508760"/>
-            <a:ext cx="3596335" cy="4901184"/>
-          </a:xfrm>
-          <a:prstGeom prst="roundRect">
-            <a:avLst/>
-          </a:prstGeom>
-          <a:solidFill>
-            <a:srgbClr val="161E31"/>
-          </a:solidFill>
-          <a:ln>
-            <a:solidFill>
-              <a:srgbClr val="2D3748"/>
-            </a:solidFill>
-          </a:ln>
-        </p:spPr>
-        <p:style>
-          <a:lnRef idx="1">
-            <a:schemeClr val="accent1"/>
-          </a:lnRef>
-          <a:fillRef idx="3">
-            <a:schemeClr val="accent1"/>
-          </a:fillRef>
-          <a:effectRef idx="2">
-            <a:schemeClr val="accent1"/>
-          </a:effectRef>
-          <a:fontRef idx="minor">
-            <a:schemeClr val="lt1"/>
-          </a:fontRef>
-        </p:style>
-        <p:txBody>
           <a:bodyPr rtlCol="0" anchor="ctr"/>
           <a:lstStyle/>
           <a:p>
@@ -10074,7 +9810,7 @@
       </p:sp>
       <p:pic>
         <p:nvPicPr>
-          <p:cNvPr id="9" name="Picture 8" descr="figma_canvas_8_screens.png"/>
+          <p:cNvPr id="8" name="Picture 7" descr="figma_canvas_8_screens.png"/>
           <p:cNvPicPr>
             <a:picLocks noChangeAspect="1"/>
           </p:cNvPicPr>
@@ -10088,8 +9824,8 @@
         </p:blipFill>
         <p:spPr>
           <a:xfrm>
-            <a:off x="8092440" y="1691640"/>
-            <a:ext cx="3139135" cy="1667665"/>
+            <a:off x="5318607" y="2304573"/>
+            <a:ext cx="6126480" cy="3254692"/>
           </a:xfrm>
           <a:prstGeom prst="rect">
             <a:avLst/>
@@ -10165,18 +9901,18 @@
         </p:nvSpPr>
         <p:spPr>
           <a:xfrm>
-            <a:off x="731520" y="365760"/>
-            <a:ext cx="10728655" cy="1005840"/>
+            <a:off x="548640" y="320040"/>
+            <a:ext cx="11094415" cy="960120"/>
           </a:xfrm>
           <a:prstGeom prst="roundRect">
             <a:avLst/>
           </a:prstGeom>
           <a:solidFill>
-            <a:srgbClr val="161E31"/>
+            <a:srgbClr val="131A2A"/>
           </a:solidFill>
           <a:ln>
             <a:solidFill>
-              <a:srgbClr val="2D3748"/>
+              <a:srgbClr val="28344B"/>
             </a:solidFill>
           </a:ln>
         </p:spPr>
@@ -10207,7 +9943,7 @@
               </a:defRPr>
             </a:pPr>
             <a:r>
-              <a:t>09 / 12  ·  DESIGN SYSTEM</a:t>
+              <a:t>09  ·  DESIGN SYSTEM</a:t>
             </a:r>
           </a:p>
           <a:p>
@@ -10223,7 +9959,7 @@
               </a:defRPr>
             </a:pPr>
             <a:r>
-              <a:t>Design Tokens &amp; 9 Nhóm Components Figma</a:t>
+              <a:t>Design Tokens &amp; 9 Nhóm Components Figma Chuẩn mực</a:t>
             </a:r>
           </a:p>
         </p:txBody>
@@ -10236,8 +9972,8 @@
         </p:nvSpPr>
         <p:spPr>
           <a:xfrm>
-            <a:off x="7772400" y="438912"/>
-            <a:ext cx="3474720" cy="457200"/>
+            <a:off x="7772400" y="384048"/>
+            <a:ext cx="3657600" cy="457200"/>
           </a:xfrm>
           <a:prstGeom prst="rect">
             <a:avLst/>
@@ -10272,18 +10008,18 @@
         </p:nvSpPr>
         <p:spPr>
           <a:xfrm>
-            <a:off x="731520" y="1508760"/>
-            <a:ext cx="6949440" cy="1554480"/>
+            <a:off x="548640" y="1417320"/>
+            <a:ext cx="8046720" cy="1584960"/>
           </a:xfrm>
           <a:prstGeom prst="roundRect">
             <a:avLst/>
           </a:prstGeom>
           <a:solidFill>
-            <a:srgbClr val="161E31"/>
+            <a:srgbClr val="131A2A"/>
           </a:solidFill>
           <a:ln>
             <a:solidFill>
-              <a:srgbClr val="2D3748"/>
+              <a:srgbClr val="28344B"/>
             </a:solidFill>
           </a:ln>
         </p:spPr>
@@ -10302,14 +10038,14 @@
           </a:fontRef>
         </p:style>
         <p:txBody>
-          <a:bodyPr rtlCol="0" anchor="ctr" lIns="228600" tIns="164592" rIns="228600" wrap="square"/>
+          <a:bodyPr rtlCol="0" anchor="ctr" lIns="228600" tIns="137160" rIns="228600" wrap="square"/>
           <a:lstStyle/>
           <a:p>
             <a:pPr algn="ctr">
               <a:spcAft>
-                <a:spcPts val="400"/>
-              </a:spcAft>
-              <a:defRPr sz="1300" b="1">
+                <a:spcPts val="300"/>
+              </a:spcAft>
+              <a:defRPr sz="1250" b="1">
                 <a:solidFill>
                   <a:srgbClr val="38BDF8"/>
                 </a:solidFill>
@@ -10325,7 +10061,7 @@
               <a:spcAft>
                 <a:spcPts val="200"/>
               </a:spcAft>
-              <a:defRPr sz="1150">
+              <a:defRPr sz="1100">
                 <a:solidFill>
                   <a:srgbClr val="E2E8F0"/>
                 </a:solidFill>
@@ -10341,7 +10077,7 @@
               <a:spcAft>
                 <a:spcPts val="200"/>
               </a:spcAft>
-              <a:defRPr sz="1150">
+              <a:defRPr sz="1100">
                 <a:solidFill>
                   <a:srgbClr val="E2E8F0"/>
                 </a:solidFill>
@@ -10357,7 +10093,7 @@
               <a:spcAft>
                 <a:spcPts val="200"/>
               </a:spcAft>
-              <a:defRPr sz="1150">
+              <a:defRPr sz="1100">
                 <a:solidFill>
                   <a:srgbClr val="E2E8F0"/>
                 </a:solidFill>
@@ -10378,18 +10114,18 @@
         </p:nvSpPr>
         <p:spPr>
           <a:xfrm>
-            <a:off x="731520" y="3182112"/>
-            <a:ext cx="6949440" cy="1554480"/>
+            <a:off x="548640" y="3139440"/>
+            <a:ext cx="8046720" cy="1584960"/>
           </a:xfrm>
           <a:prstGeom prst="roundRect">
             <a:avLst/>
           </a:prstGeom>
           <a:solidFill>
-            <a:srgbClr val="161E31"/>
+            <a:srgbClr val="131A2A"/>
           </a:solidFill>
           <a:ln>
             <a:solidFill>
-              <a:srgbClr val="2D3748"/>
+              <a:srgbClr val="28344B"/>
             </a:solidFill>
           </a:ln>
         </p:spPr>
@@ -10408,14 +10144,14 @@
           </a:fontRef>
         </p:style>
         <p:txBody>
-          <a:bodyPr rtlCol="0" anchor="ctr" lIns="228600" tIns="164592" rIns="228600" wrap="square"/>
+          <a:bodyPr rtlCol="0" anchor="ctr" lIns="228600" tIns="137160" rIns="228600" wrap="square"/>
           <a:lstStyle/>
           <a:p>
             <a:pPr algn="ctr">
               <a:spcAft>
-                <a:spcPts val="400"/>
-              </a:spcAft>
-              <a:defRPr sz="1300" b="1">
+                <a:spcPts val="300"/>
+              </a:spcAft>
+              <a:defRPr sz="1250" b="1">
                 <a:solidFill>
                   <a:srgbClr val="34D399"/>
                 </a:solidFill>
@@ -10431,7 +10167,7 @@
               <a:spcAft>
                 <a:spcPts val="200"/>
               </a:spcAft>
-              <a:defRPr sz="1150">
+              <a:defRPr sz="1100">
                 <a:solidFill>
                   <a:srgbClr val="E2E8F0"/>
                 </a:solidFill>
@@ -10447,7 +10183,7 @@
               <a:spcAft>
                 <a:spcPts val="200"/>
               </a:spcAft>
-              <a:defRPr sz="1150">
+              <a:defRPr sz="1100">
                 <a:solidFill>
                   <a:srgbClr val="E2E8F0"/>
                 </a:solidFill>
@@ -10463,7 +10199,7 @@
               <a:spcAft>
                 <a:spcPts val="200"/>
               </a:spcAft>
-              <a:defRPr sz="1150">
+              <a:defRPr sz="1100">
                 <a:solidFill>
                   <a:srgbClr val="E2E8F0"/>
                 </a:solidFill>
@@ -10479,7 +10215,7 @@
               <a:spcAft>
                 <a:spcPts val="200"/>
               </a:spcAft>
-              <a:defRPr sz="1150">
+              <a:defRPr sz="1100">
                 <a:solidFill>
                   <a:srgbClr val="E2E8F0"/>
                 </a:solidFill>
@@ -10500,18 +10236,18 @@
         </p:nvSpPr>
         <p:spPr>
           <a:xfrm>
-            <a:off x="731520" y="4855464"/>
-            <a:ext cx="6949440" cy="1554480"/>
+            <a:off x="548640" y="4861560"/>
+            <a:ext cx="8046720" cy="1584960"/>
           </a:xfrm>
           <a:prstGeom prst="roundRect">
             <a:avLst/>
           </a:prstGeom>
           <a:solidFill>
-            <a:srgbClr val="161E31"/>
+            <a:srgbClr val="131A2A"/>
           </a:solidFill>
           <a:ln>
             <a:solidFill>
-              <a:srgbClr val="2D3748"/>
+              <a:srgbClr val="28344B"/>
             </a:solidFill>
           </a:ln>
         </p:spPr>
@@ -10530,14 +10266,14 @@
           </a:fontRef>
         </p:style>
         <p:txBody>
-          <a:bodyPr rtlCol="0" anchor="ctr" lIns="228600" tIns="164592" rIns="228600" wrap="square"/>
+          <a:bodyPr rtlCol="0" anchor="ctr" lIns="228600" tIns="137160" rIns="228600" wrap="square"/>
           <a:lstStyle/>
           <a:p>
             <a:pPr algn="ctr">
               <a:spcAft>
-                <a:spcPts val="400"/>
-              </a:spcAft>
-              <a:defRPr sz="1300" b="1">
+                <a:spcPts val="300"/>
+              </a:spcAft>
+              <a:defRPr sz="1250" b="1">
                 <a:solidFill>
                   <a:srgbClr val="38BDF8"/>
                 </a:solidFill>
@@ -10553,15 +10289,15 @@
               <a:spcAft>
                 <a:spcPts val="200"/>
               </a:spcAft>
-              <a:defRPr sz="1150">
-                <a:solidFill>
-                  <a:srgbClr val="94A3B8"/>
-                </a:solidFill>
-                <a:latin typeface="Arial"/>
-              </a:defRPr>
-            </a:pPr>
-            <a:r>
-              <a:t>• Figma Page 04 Design System &amp; Page 05 Components.</a:t>
+              <a:defRPr sz="1100">
+                <a:solidFill>
+                  <a:srgbClr val="E2E8F0"/>
+                </a:solidFill>
+                <a:latin typeface="Arial"/>
+              </a:defRPr>
+            </a:pPr>
+            <a:r>
+              <a:t>• Trực quan hóa tại Figma Page 04 Design System &amp; Page 05 Components.</a:t>
             </a:r>
           </a:p>
         </p:txBody>
@@ -10574,18 +10310,18 @@
         </p:nvSpPr>
         <p:spPr>
           <a:xfrm>
-            <a:off x="7863840" y="1508760"/>
-            <a:ext cx="3596335" cy="4901184"/>
+            <a:off x="8778240" y="1417320"/>
+            <a:ext cx="2864815" cy="5029200"/>
           </a:xfrm>
           <a:prstGeom prst="roundRect">
             <a:avLst/>
           </a:prstGeom>
           <a:solidFill>
-            <a:srgbClr val="161E31"/>
+            <a:srgbClr val="131A2A"/>
           </a:solidFill>
           <a:ln>
             <a:solidFill>
-              <a:srgbClr val="2D3748"/>
+              <a:srgbClr val="28344B"/>
             </a:solidFill>
           </a:ln>
         </p:spPr>
@@ -10627,8 +10363,8 @@
         </p:blipFill>
         <p:spPr>
           <a:xfrm>
-            <a:off x="8092440" y="1691640"/>
-            <a:ext cx="3139135" cy="14951043"/>
+            <a:off x="9711477" y="1554480"/>
+            <a:ext cx="998339" cy="4754880"/>
           </a:xfrm>
           <a:prstGeom prst="rect">
             <a:avLst/>

</xml_diff>

<commit_message>
docs: finalize 12-slide presentation deck with interactive web, high-res PDF and PPTX
</commit_message>
<xml_diff>
--- a/docs/PRM323_Lab2_Nhom4_Slides.pptx
+++ b/docs/PRM323_Lab2_Nhom4_Slides.pptx
@@ -4860,7 +4860,7 @@
       </p:sp>
       <p:pic>
         <p:nvPicPr>
-          <p:cNvPr id="9" name="Picture 8" descr="screen_01_discovery_feed.png"/>
+          <p:cNvPr id="9" name="Picture 8" descr="screen_01_discovery_feed_crop_fold.png"/>
           <p:cNvPicPr>
             <a:picLocks noChangeAspect="1"/>
           </p:cNvPicPr>
@@ -4874,8 +4874,8 @@
         </p:blipFill>
         <p:spPr>
           <a:xfrm>
-            <a:off x="9681295" y="1554480"/>
-            <a:ext cx="1058703" cy="4754880"/>
+            <a:off x="9072248" y="1600200"/>
+            <a:ext cx="2276797" cy="4663440"/>
           </a:xfrm>
           <a:prstGeom prst="rect">
             <a:avLst/>
@@ -5383,7 +5383,7 @@
       </p:sp>
       <p:pic>
         <p:nvPicPr>
-          <p:cNvPr id="9" name="Picture 8" descr="screen_06_chemistry_call_modal.png"/>
+          <p:cNvPr id="9" name="Picture 8" descr="screen_06_chemistry_call_modal_crop_fold.png"/>
           <p:cNvPicPr>
             <a:picLocks noChangeAspect="1"/>
           </p:cNvPicPr>
@@ -5397,8 +5397,8 @@
         </p:blipFill>
         <p:spPr>
           <a:xfrm>
-            <a:off x="9163552" y="1554480"/>
-            <a:ext cx="2094190" cy="4754880"/>
+            <a:off x="9072546" y="1600200"/>
+            <a:ext cx="2276202" cy="4663440"/>
           </a:xfrm>
           <a:prstGeom prst="rect">
             <a:avLst/>
@@ -5906,7 +5906,7 @@
       </p:sp>
       <p:pic>
         <p:nvPicPr>
-          <p:cNvPr id="9" name="Picture 8" descr="screen_07_chemistry_call_confirmed.png"/>
+          <p:cNvPr id="9" name="Picture 8" descr="screen_07_chemistry_call_confirmed_crop_fold.png"/>
           <p:cNvPicPr>
             <a:picLocks noChangeAspect="1"/>
           </p:cNvPicPr>
@@ -5920,8 +5920,8 @@
         </p:blipFill>
         <p:spPr>
           <a:xfrm>
-            <a:off x="9846137" y="1554480"/>
-            <a:ext cx="729019" cy="4754880"/>
+            <a:off x="9070211" y="1600200"/>
+            <a:ext cx="2280872" cy="4663440"/>
           </a:xfrm>
           <a:prstGeom prst="rect">
             <a:avLst/>
@@ -6445,7 +6445,7 @@
       </p:sp>
       <p:pic>
         <p:nvPicPr>
-          <p:cNvPr id="9" name="Picture 8" descr="screen_04_application_submitted.png"/>
+          <p:cNvPr id="9" name="Picture 8" descr="screen_04_application_submitted_crop_fold.png"/>
           <p:cNvPicPr>
             <a:picLocks noChangeAspect="1"/>
           </p:cNvPicPr>
@@ -6459,8 +6459,8 @@
         </p:blipFill>
         <p:spPr>
           <a:xfrm>
-            <a:off x="9646469" y="1554480"/>
-            <a:ext cx="1128355" cy="4754880"/>
+            <a:off x="9072880" y="1600200"/>
+            <a:ext cx="2275533" cy="4663440"/>
           </a:xfrm>
           <a:prstGeom prst="rect">
             <a:avLst/>
@@ -6952,7 +6952,7 @@
       </p:sp>
       <p:pic>
         <p:nvPicPr>
-          <p:cNvPr id="9" name="Picture 8" descr="screen_02_project_detail.png"/>
+          <p:cNvPr id="9" name="Picture 8" descr="screen_02_project_detail_crop_fold.png"/>
           <p:cNvPicPr>
             <a:picLocks noChangeAspect="1"/>
           </p:cNvPicPr>
@@ -6966,8 +6966,8 @@
         </p:blipFill>
         <p:spPr>
           <a:xfrm>
-            <a:off x="9630217" y="1554480"/>
-            <a:ext cx="1160859" cy="4754880"/>
+            <a:off x="9072112" y="1600200"/>
+            <a:ext cx="2277070" cy="4663440"/>
           </a:xfrm>
           <a:prstGeom prst="rect">
             <a:avLst/>
@@ -7860,7 +7860,7 @@
       </p:sp>
       <p:pic>
         <p:nvPicPr>
-          <p:cNvPr id="9" name="Picture 8" descr="screen_08_empty_state.png"/>
+          <p:cNvPr id="9" name="Picture 8" descr="screen_08_empty_state_crop_fold.png"/>
           <p:cNvPicPr>
             <a:picLocks noChangeAspect="1"/>
           </p:cNvPicPr>
@@ -7874,8 +7874,8 @@
         </p:blipFill>
         <p:spPr>
           <a:xfrm>
-            <a:off x="9648791" y="1554480"/>
-            <a:ext cx="1123711" cy="4754880"/>
+            <a:off x="9072993" y="1600200"/>
+            <a:ext cx="2275307" cy="4663440"/>
           </a:xfrm>
           <a:prstGeom prst="rect">
             <a:avLst/>
@@ -9297,7 +9297,7 @@
       </p:sp>
       <p:pic>
         <p:nvPicPr>
-          <p:cNvPr id="9" name="Picture 8" descr="screen_03_apply_sheet.png"/>
+          <p:cNvPr id="9" name="Picture 8" descr="screen_03_apply_sheet_crop_fold.png"/>
           <p:cNvPicPr>
             <a:picLocks noChangeAspect="1"/>
           </p:cNvPicPr>
@@ -9311,8 +9311,8 @@
         </p:blipFill>
         <p:spPr>
           <a:xfrm>
-            <a:off x="9581461" y="1554480"/>
-            <a:ext cx="1258371" cy="4754880"/>
+            <a:off x="9072095" y="1600200"/>
+            <a:ext cx="2277103" cy="4663440"/>
           </a:xfrm>
           <a:prstGeom prst="rect">
             <a:avLst/>
@@ -9810,7 +9810,7 @@
       </p:sp>
       <p:pic>
         <p:nvPicPr>
-          <p:cNvPr id="8" name="Picture 7" descr="figma_canvas_8_screens.png"/>
+          <p:cNvPr id="8" name="Picture 7" descr="screens_8_showcase_wide.png"/>
           <p:cNvPicPr>
             <a:picLocks noChangeAspect="1"/>
           </p:cNvPicPr>
@@ -9824,8 +9824,8 @@
         </p:blipFill>
         <p:spPr>
           <a:xfrm>
-            <a:off x="5318607" y="2304573"/>
-            <a:ext cx="6126480" cy="3254692"/>
+            <a:off x="5318607" y="2719387"/>
+            <a:ext cx="6126480" cy="2425065"/>
           </a:xfrm>
           <a:prstGeom prst="rect">
             <a:avLst/>
@@ -10349,7 +10349,7 @@
       </p:sp>
       <p:pic>
         <p:nvPicPr>
-          <p:cNvPr id="9" name="Picture 8" descr="screen_05_my_applications_tracker.png"/>
+          <p:cNvPr id="9" name="Picture 8" descr="screen_05_my_applications_tracker_crop_fold.png"/>
           <p:cNvPicPr>
             <a:picLocks noChangeAspect="1"/>
           </p:cNvPicPr>
@@ -10363,8 +10363,8 @@
         </p:blipFill>
         <p:spPr>
           <a:xfrm>
-            <a:off x="9711477" y="1554480"/>
-            <a:ext cx="998339" cy="4754880"/>
+            <a:off x="9071284" y="1600200"/>
+            <a:ext cx="2278726" cy="4663440"/>
           </a:xfrm>
           <a:prstGeom prst="rect">
             <a:avLst/>

</xml_diff>